<commit_message>
sanity check on crumb
</commit_message>
<xml_diff>
--- a/classifier-guided-physics-informed-diffusion/ZAMLA_talk.pptx
+++ b/classifier-guided-physics-informed-diffusion/ZAMLA_talk.pptx
@@ -5,22 +5,22 @@
     <p:sldMasterId id="2147483648" r:id="rId1"/>
   </p:sldMasterIdLst>
   <p:sldIdLst>
-    <p:sldId id="256" r:id="rId7"/>
-    <p:sldId id="257" r:id="rId8"/>
-    <p:sldId id="258" r:id="rId9"/>
-    <p:sldId id="259" r:id="rId10"/>
-    <p:sldId id="260" r:id="rId11"/>
-    <p:sldId id="261" r:id="rId12"/>
-    <p:sldId id="262" r:id="rId13"/>
-    <p:sldId id="263" r:id="rId14"/>
-    <p:sldId id="264" r:id="rId15"/>
-    <p:sldId id="265" r:id="rId16"/>
-    <p:sldId id="266" r:id="rId17"/>
-    <p:sldId id="267" r:id="rId18"/>
-    <p:sldId id="268" r:id="rId19"/>
-    <p:sldId id="269" r:id="rId20"/>
+    <p:sldId id="256" r:id="rId2"/>
+    <p:sldId id="257" r:id="rId3"/>
+    <p:sldId id="258" r:id="rId4"/>
+    <p:sldId id="272" r:id="rId5"/>
+    <p:sldId id="270" r:id="rId6"/>
+    <p:sldId id="259" r:id="rId7"/>
+    <p:sldId id="260" r:id="rId8"/>
+    <p:sldId id="261" r:id="rId9"/>
+    <p:sldId id="263" r:id="rId10"/>
+    <p:sldId id="264" r:id="rId11"/>
+    <p:sldId id="265" r:id="rId12"/>
+    <p:sldId id="266" r:id="rId13"/>
+    <p:sldId id="268" r:id="rId14"/>
+    <p:sldId id="269" r:id="rId15"/>
   </p:sldIdLst>
-  <p:sldSz cx="12191695" cy="6858000" type="screen4x3"/>
+  <p:sldSz cx="12192000" cy="6858000"/>
   <p:notesSz cx="6858000" cy="9144000"/>
   <p:defaultTextStyle>
     <a:defPPr>
@@ -117,6 +117,22 @@
       </a:defRPr>
     </a:lvl9pPr>
   </p:defaultTextStyle>
+  <p:extLst>
+    <p:ext uri="{EFAFB233-063F-42B5-8137-9DF3F51BA10A}">
+      <p15:sldGuideLst xmlns:p15="http://schemas.microsoft.com/office/powerpoint/2012/main">
+        <p15:guide id="1" orient="horz" pos="2160">
+          <p15:clr>
+            <a:srgbClr val="A4A3A4"/>
+          </p15:clr>
+        </p15:guide>
+        <p15:guide id="2" pos="2880">
+          <p15:clr>
+            <a:srgbClr val="A4A3A4"/>
+          </p15:clr>
+        </p15:guide>
+      </p15:sldGuideLst>
+    </p:ext>
+  </p:extLst>
 </p:presentation>
 </file>
 
@@ -158,10 +174,9 @@
           <a:lstStyle/>
           <a:p>
             <a:r>
-              <a:rPr lang="en-US" smtClean="0"/>
+              <a:rPr lang="en-US"/>
               <a:t>Click to edit Master title style</a:t>
             </a:r>
-            <a:endParaRPr lang="en-US"/>
           </a:p>
         </p:txBody>
       </p:sp>
@@ -277,10 +292,9 @@
           </a:lstStyle>
           <a:p>
             <a:r>
-              <a:rPr lang="en-US" smtClean="0"/>
+              <a:rPr lang="en-US"/>
               <a:t>Click to edit Master subtitle style</a:t>
             </a:r>
-            <a:endParaRPr lang="en-US"/>
           </a:p>
         </p:txBody>
       </p:sp>
@@ -301,7 +315,7 @@
           <a:p>
             <a:fld id="{5BCAD085-E8A6-8845-BD4E-CB4CCA059FC4}" type="datetimeFigureOut">
               <a:rPr lang="en-US" smtClean="0"/>
-              <a:t>1/27/13</a:t>
+              <a:t>7/9/26</a:t>
             </a:fld>
             <a:endParaRPr lang="en-US"/>
           </a:p>
@@ -395,10 +409,9 @@
           <a:lstStyle/>
           <a:p>
             <a:r>
-              <a:rPr lang="en-US" smtClean="0"/>
+              <a:rPr lang="en-US"/>
               <a:t>Click to edit Master title style</a:t>
             </a:r>
-            <a:endParaRPr lang="en-US"/>
           </a:p>
         </p:txBody>
       </p:sp>
@@ -419,38 +432,37 @@
           <a:p>
             <a:pPr lvl="0"/>
             <a:r>
-              <a:rPr lang="en-US" smtClean="0"/>
+              <a:rPr lang="en-US"/>
               <a:t>Click to edit Master text styles</a:t>
             </a:r>
           </a:p>
           <a:p>
             <a:pPr lvl="1"/>
             <a:r>
-              <a:rPr lang="en-US" smtClean="0"/>
+              <a:rPr lang="en-US"/>
               <a:t>Second level</a:t>
             </a:r>
           </a:p>
           <a:p>
             <a:pPr lvl="2"/>
             <a:r>
-              <a:rPr lang="en-US" smtClean="0"/>
+              <a:rPr lang="en-US"/>
               <a:t>Third level</a:t>
             </a:r>
           </a:p>
           <a:p>
             <a:pPr lvl="3"/>
             <a:r>
-              <a:rPr lang="en-US" smtClean="0"/>
+              <a:rPr lang="en-US"/>
               <a:t>Fourth level</a:t>
             </a:r>
           </a:p>
           <a:p>
             <a:pPr lvl="4"/>
             <a:r>
-              <a:rPr lang="en-US" smtClean="0"/>
+              <a:rPr lang="en-US"/>
               <a:t>Fifth level</a:t>
             </a:r>
-            <a:endParaRPr lang="en-US"/>
           </a:p>
         </p:txBody>
       </p:sp>
@@ -471,7 +483,7 @@
           <a:p>
             <a:fld id="{5BCAD085-E8A6-8845-BD4E-CB4CCA059FC4}" type="datetimeFigureOut">
               <a:rPr lang="en-US" smtClean="0"/>
-              <a:t>1/27/13</a:t>
+              <a:t>7/9/26</a:t>
             </a:fld>
             <a:endParaRPr lang="en-US"/>
           </a:p>
@@ -570,10 +582,9 @@
           <a:lstStyle/>
           <a:p>
             <a:r>
-              <a:rPr lang="en-US" smtClean="0"/>
+              <a:rPr lang="en-US"/>
               <a:t>Click to edit Master title style</a:t>
             </a:r>
-            <a:endParaRPr lang="en-US"/>
           </a:p>
         </p:txBody>
       </p:sp>
@@ -599,38 +610,37 @@
           <a:p>
             <a:pPr lvl="0"/>
             <a:r>
-              <a:rPr lang="en-US" smtClean="0"/>
+              <a:rPr lang="en-US"/>
               <a:t>Click to edit Master text styles</a:t>
             </a:r>
           </a:p>
           <a:p>
             <a:pPr lvl="1"/>
             <a:r>
-              <a:rPr lang="en-US" smtClean="0"/>
+              <a:rPr lang="en-US"/>
               <a:t>Second level</a:t>
             </a:r>
           </a:p>
           <a:p>
             <a:pPr lvl="2"/>
             <a:r>
-              <a:rPr lang="en-US" smtClean="0"/>
+              <a:rPr lang="en-US"/>
               <a:t>Third level</a:t>
             </a:r>
           </a:p>
           <a:p>
             <a:pPr lvl="3"/>
             <a:r>
-              <a:rPr lang="en-US" smtClean="0"/>
+              <a:rPr lang="en-US"/>
               <a:t>Fourth level</a:t>
             </a:r>
           </a:p>
           <a:p>
             <a:pPr lvl="4"/>
             <a:r>
-              <a:rPr lang="en-US" smtClean="0"/>
+              <a:rPr lang="en-US"/>
               <a:t>Fifth level</a:t>
             </a:r>
-            <a:endParaRPr lang="en-US"/>
           </a:p>
         </p:txBody>
       </p:sp>
@@ -651,7 +661,7 @@
           <a:p>
             <a:fld id="{5BCAD085-E8A6-8845-BD4E-CB4CCA059FC4}" type="datetimeFigureOut">
               <a:rPr lang="en-US" smtClean="0"/>
-              <a:t>1/27/13</a:t>
+              <a:t>7/9/26</a:t>
             </a:fld>
             <a:endParaRPr lang="en-US"/>
           </a:p>
@@ -745,10 +755,9 @@
           <a:lstStyle/>
           <a:p>
             <a:r>
-              <a:rPr lang="en-US" smtClean="0"/>
+              <a:rPr lang="en-US"/>
               <a:t>Click to edit Master title style</a:t>
             </a:r>
-            <a:endParaRPr lang="en-US"/>
           </a:p>
         </p:txBody>
       </p:sp>
@@ -769,38 +778,37 @@
           <a:p>
             <a:pPr lvl="0"/>
             <a:r>
-              <a:rPr lang="en-US" smtClean="0"/>
+              <a:rPr lang="en-US"/>
               <a:t>Click to edit Master text styles</a:t>
             </a:r>
           </a:p>
           <a:p>
             <a:pPr lvl="1"/>
             <a:r>
-              <a:rPr lang="en-US" smtClean="0"/>
+              <a:rPr lang="en-US"/>
               <a:t>Second level</a:t>
             </a:r>
           </a:p>
           <a:p>
             <a:pPr lvl="2"/>
             <a:r>
-              <a:rPr lang="en-US" smtClean="0"/>
+              <a:rPr lang="en-US"/>
               <a:t>Third level</a:t>
             </a:r>
           </a:p>
           <a:p>
             <a:pPr lvl="3"/>
             <a:r>
-              <a:rPr lang="en-US" smtClean="0"/>
+              <a:rPr lang="en-US"/>
               <a:t>Fourth level</a:t>
             </a:r>
           </a:p>
           <a:p>
             <a:pPr lvl="4"/>
             <a:r>
-              <a:rPr lang="en-US" smtClean="0"/>
+              <a:rPr lang="en-US"/>
               <a:t>Fifth level</a:t>
             </a:r>
-            <a:endParaRPr lang="en-US"/>
           </a:p>
         </p:txBody>
       </p:sp>
@@ -821,7 +829,7 @@
           <a:p>
             <a:fld id="{5BCAD085-E8A6-8845-BD4E-CB4CCA059FC4}" type="datetimeFigureOut">
               <a:rPr lang="en-US" smtClean="0"/>
-              <a:t>1/27/13</a:t>
+              <a:t>7/9/26</a:t>
             </a:fld>
             <a:endParaRPr lang="en-US"/>
           </a:p>
@@ -924,10 +932,9 @@
           </a:lstStyle>
           <a:p>
             <a:r>
-              <a:rPr lang="en-US" smtClean="0"/>
+              <a:rPr lang="en-US"/>
               <a:t>Click to edit Master title style</a:t>
             </a:r>
-            <a:endParaRPr lang="en-US"/>
           </a:p>
         </p:txBody>
       </p:sp>
@@ -1044,7 +1051,7 @@
           <a:p>
             <a:pPr lvl="0"/>
             <a:r>
-              <a:rPr lang="en-US" smtClean="0"/>
+              <a:rPr lang="en-US"/>
               <a:t>Click to edit Master text styles</a:t>
             </a:r>
           </a:p>
@@ -1067,7 +1074,7 @@
           <a:p>
             <a:fld id="{5BCAD085-E8A6-8845-BD4E-CB4CCA059FC4}" type="datetimeFigureOut">
               <a:rPr lang="en-US" smtClean="0"/>
-              <a:t>1/27/13</a:t>
+              <a:t>7/9/26</a:t>
             </a:fld>
             <a:endParaRPr lang="en-US"/>
           </a:p>
@@ -1161,10 +1168,9 @@
           <a:lstStyle/>
           <a:p>
             <a:r>
-              <a:rPr lang="en-US" smtClean="0"/>
+              <a:rPr lang="en-US"/>
               <a:t>Click to edit Master title style</a:t>
             </a:r>
-            <a:endParaRPr lang="en-US"/>
           </a:p>
         </p:txBody>
       </p:sp>
@@ -1218,38 +1224,37 @@
           <a:p>
             <a:pPr lvl="0"/>
             <a:r>
-              <a:rPr lang="en-US" smtClean="0"/>
+              <a:rPr lang="en-US"/>
               <a:t>Click to edit Master text styles</a:t>
             </a:r>
           </a:p>
           <a:p>
             <a:pPr lvl="1"/>
             <a:r>
-              <a:rPr lang="en-US" smtClean="0"/>
+              <a:rPr lang="en-US"/>
               <a:t>Second level</a:t>
             </a:r>
           </a:p>
           <a:p>
             <a:pPr lvl="2"/>
             <a:r>
-              <a:rPr lang="en-US" smtClean="0"/>
+              <a:rPr lang="en-US"/>
               <a:t>Third level</a:t>
             </a:r>
           </a:p>
           <a:p>
             <a:pPr lvl="3"/>
             <a:r>
-              <a:rPr lang="en-US" smtClean="0"/>
+              <a:rPr lang="en-US"/>
               <a:t>Fourth level</a:t>
             </a:r>
           </a:p>
           <a:p>
             <a:pPr lvl="4"/>
             <a:r>
-              <a:rPr lang="en-US" smtClean="0"/>
+              <a:rPr lang="en-US"/>
               <a:t>Fifth level</a:t>
             </a:r>
-            <a:endParaRPr lang="en-US"/>
           </a:p>
         </p:txBody>
       </p:sp>
@@ -1303,38 +1308,37 @@
           <a:p>
             <a:pPr lvl="0"/>
             <a:r>
-              <a:rPr lang="en-US" smtClean="0"/>
+              <a:rPr lang="en-US"/>
               <a:t>Click to edit Master text styles</a:t>
             </a:r>
           </a:p>
           <a:p>
             <a:pPr lvl="1"/>
             <a:r>
-              <a:rPr lang="en-US" smtClean="0"/>
+              <a:rPr lang="en-US"/>
               <a:t>Second level</a:t>
             </a:r>
           </a:p>
           <a:p>
             <a:pPr lvl="2"/>
             <a:r>
-              <a:rPr lang="en-US" smtClean="0"/>
+              <a:rPr lang="en-US"/>
               <a:t>Third level</a:t>
             </a:r>
           </a:p>
           <a:p>
             <a:pPr lvl="3"/>
             <a:r>
-              <a:rPr lang="en-US" smtClean="0"/>
+              <a:rPr lang="en-US"/>
               <a:t>Fourth level</a:t>
             </a:r>
           </a:p>
           <a:p>
             <a:pPr lvl="4"/>
             <a:r>
-              <a:rPr lang="en-US" smtClean="0"/>
+              <a:rPr lang="en-US"/>
               <a:t>Fifth level</a:t>
             </a:r>
-            <a:endParaRPr lang="en-US"/>
           </a:p>
         </p:txBody>
       </p:sp>
@@ -1355,7 +1359,7 @@
           <a:p>
             <a:fld id="{5BCAD085-E8A6-8845-BD4E-CB4CCA059FC4}" type="datetimeFigureOut">
               <a:rPr lang="en-US" smtClean="0"/>
-              <a:t>1/27/13</a:t>
+              <a:t>7/9/26</a:t>
             </a:fld>
             <a:endParaRPr lang="en-US"/>
           </a:p>
@@ -1453,10 +1457,9 @@
           </a:lstStyle>
           <a:p>
             <a:r>
-              <a:rPr lang="en-US" smtClean="0"/>
+              <a:rPr lang="en-US"/>
               <a:t>Click to edit Master title style</a:t>
             </a:r>
-            <a:endParaRPr lang="en-US"/>
           </a:p>
         </p:txBody>
       </p:sp>
@@ -1519,7 +1522,7 @@
           <a:p>
             <a:pPr lvl="0"/>
             <a:r>
-              <a:rPr lang="en-US" smtClean="0"/>
+              <a:rPr lang="en-US"/>
               <a:t>Click to edit Master text styles</a:t>
             </a:r>
           </a:p>
@@ -1575,38 +1578,37 @@
           <a:p>
             <a:pPr lvl="0"/>
             <a:r>
-              <a:rPr lang="en-US" smtClean="0"/>
+              <a:rPr lang="en-US"/>
               <a:t>Click to edit Master text styles</a:t>
             </a:r>
           </a:p>
           <a:p>
             <a:pPr lvl="1"/>
             <a:r>
-              <a:rPr lang="en-US" smtClean="0"/>
+              <a:rPr lang="en-US"/>
               <a:t>Second level</a:t>
             </a:r>
           </a:p>
           <a:p>
             <a:pPr lvl="2"/>
             <a:r>
-              <a:rPr lang="en-US" smtClean="0"/>
+              <a:rPr lang="en-US"/>
               <a:t>Third level</a:t>
             </a:r>
           </a:p>
           <a:p>
             <a:pPr lvl="3"/>
             <a:r>
-              <a:rPr lang="en-US" smtClean="0"/>
+              <a:rPr lang="en-US"/>
               <a:t>Fourth level</a:t>
             </a:r>
           </a:p>
           <a:p>
             <a:pPr lvl="4"/>
             <a:r>
-              <a:rPr lang="en-US" smtClean="0"/>
+              <a:rPr lang="en-US"/>
               <a:t>Fifth level</a:t>
             </a:r>
-            <a:endParaRPr lang="en-US"/>
           </a:p>
         </p:txBody>
       </p:sp>
@@ -1669,7 +1671,7 @@
           <a:p>
             <a:pPr lvl="0"/>
             <a:r>
-              <a:rPr lang="en-US" smtClean="0"/>
+              <a:rPr lang="en-US"/>
               <a:t>Click to edit Master text styles</a:t>
             </a:r>
           </a:p>
@@ -1725,38 +1727,37 @@
           <a:p>
             <a:pPr lvl="0"/>
             <a:r>
-              <a:rPr lang="en-US" smtClean="0"/>
+              <a:rPr lang="en-US"/>
               <a:t>Click to edit Master text styles</a:t>
             </a:r>
           </a:p>
           <a:p>
             <a:pPr lvl="1"/>
             <a:r>
-              <a:rPr lang="en-US" smtClean="0"/>
+              <a:rPr lang="en-US"/>
               <a:t>Second level</a:t>
             </a:r>
           </a:p>
           <a:p>
             <a:pPr lvl="2"/>
             <a:r>
-              <a:rPr lang="en-US" smtClean="0"/>
+              <a:rPr lang="en-US"/>
               <a:t>Third level</a:t>
             </a:r>
           </a:p>
           <a:p>
             <a:pPr lvl="3"/>
             <a:r>
-              <a:rPr lang="en-US" smtClean="0"/>
+              <a:rPr lang="en-US"/>
               <a:t>Fourth level</a:t>
             </a:r>
           </a:p>
           <a:p>
             <a:pPr lvl="4"/>
             <a:r>
-              <a:rPr lang="en-US" smtClean="0"/>
+              <a:rPr lang="en-US"/>
               <a:t>Fifth level</a:t>
             </a:r>
-            <a:endParaRPr lang="en-US"/>
           </a:p>
         </p:txBody>
       </p:sp>
@@ -1777,7 +1778,7 @@
           <a:p>
             <a:fld id="{5BCAD085-E8A6-8845-BD4E-CB4CCA059FC4}" type="datetimeFigureOut">
               <a:rPr lang="en-US" smtClean="0"/>
-              <a:t>1/27/13</a:t>
+              <a:t>7/9/26</a:t>
             </a:fld>
             <a:endParaRPr lang="en-US"/>
           </a:p>
@@ -1871,10 +1872,9 @@
           <a:lstStyle/>
           <a:p>
             <a:r>
-              <a:rPr lang="en-US" smtClean="0"/>
+              <a:rPr lang="en-US"/>
               <a:t>Click to edit Master title style</a:t>
             </a:r>
-            <a:endParaRPr lang="en-US"/>
           </a:p>
         </p:txBody>
       </p:sp>
@@ -1895,7 +1895,7 @@
           <a:p>
             <a:fld id="{5BCAD085-E8A6-8845-BD4E-CB4CCA059FC4}" type="datetimeFigureOut">
               <a:rPr lang="en-US" smtClean="0"/>
-              <a:t>1/27/13</a:t>
+              <a:t>7/9/26</a:t>
             </a:fld>
             <a:endParaRPr lang="en-US"/>
           </a:p>
@@ -1990,7 +1990,7 @@
           <a:p>
             <a:fld id="{5BCAD085-E8A6-8845-BD4E-CB4CCA059FC4}" type="datetimeFigureOut">
               <a:rPr lang="en-US" smtClean="0"/>
-              <a:t>1/27/13</a:t>
+              <a:t>7/9/26</a:t>
             </a:fld>
             <a:endParaRPr lang="en-US"/>
           </a:p>
@@ -2093,10 +2093,9 @@
           </a:lstStyle>
           <a:p>
             <a:r>
-              <a:rPr lang="en-US" smtClean="0"/>
+              <a:rPr lang="en-US"/>
               <a:t>Click to edit Master title style</a:t>
             </a:r>
-            <a:endParaRPr lang="en-US"/>
           </a:p>
         </p:txBody>
       </p:sp>
@@ -2150,38 +2149,37 @@
           <a:p>
             <a:pPr lvl="0"/>
             <a:r>
-              <a:rPr lang="en-US" smtClean="0"/>
+              <a:rPr lang="en-US"/>
               <a:t>Click to edit Master text styles</a:t>
             </a:r>
           </a:p>
           <a:p>
             <a:pPr lvl="1"/>
             <a:r>
-              <a:rPr lang="en-US" smtClean="0"/>
+              <a:rPr lang="en-US"/>
               <a:t>Second level</a:t>
             </a:r>
           </a:p>
           <a:p>
             <a:pPr lvl="2"/>
             <a:r>
-              <a:rPr lang="en-US" smtClean="0"/>
+              <a:rPr lang="en-US"/>
               <a:t>Third level</a:t>
             </a:r>
           </a:p>
           <a:p>
             <a:pPr lvl="3"/>
             <a:r>
-              <a:rPr lang="en-US" smtClean="0"/>
+              <a:rPr lang="en-US"/>
               <a:t>Fourth level</a:t>
             </a:r>
           </a:p>
           <a:p>
             <a:pPr lvl="4"/>
             <a:r>
-              <a:rPr lang="en-US" smtClean="0"/>
+              <a:rPr lang="en-US"/>
               <a:t>Fifth level</a:t>
             </a:r>
-            <a:endParaRPr lang="en-US"/>
           </a:p>
         </p:txBody>
       </p:sp>
@@ -2244,7 +2242,7 @@
           <a:p>
             <a:pPr lvl="0"/>
             <a:r>
-              <a:rPr lang="en-US" smtClean="0"/>
+              <a:rPr lang="en-US"/>
               <a:t>Click to edit Master text styles</a:t>
             </a:r>
           </a:p>
@@ -2267,7 +2265,7 @@
           <a:p>
             <a:fld id="{5BCAD085-E8A6-8845-BD4E-CB4CCA059FC4}" type="datetimeFigureOut">
               <a:rPr lang="en-US" smtClean="0"/>
-              <a:t>1/27/13</a:t>
+              <a:t>7/9/26</a:t>
             </a:fld>
             <a:endParaRPr lang="en-US"/>
           </a:p>
@@ -2370,10 +2368,9 @@
           </a:lstStyle>
           <a:p>
             <a:r>
-              <a:rPr lang="en-US" smtClean="0"/>
+              <a:rPr lang="en-US"/>
               <a:t>Click to edit Master title style</a:t>
             </a:r>
-            <a:endParaRPr lang="en-US"/>
           </a:p>
         </p:txBody>
       </p:sp>
@@ -2497,7 +2494,7 @@
           <a:p>
             <a:pPr lvl="0"/>
             <a:r>
-              <a:rPr lang="en-US" smtClean="0"/>
+              <a:rPr lang="en-US"/>
               <a:t>Click to edit Master text styles</a:t>
             </a:r>
           </a:p>
@@ -2520,7 +2517,7 @@
           <a:p>
             <a:fld id="{5BCAD085-E8A6-8845-BD4E-CB4CCA059FC4}" type="datetimeFigureOut">
               <a:rPr lang="en-US" smtClean="0"/>
-              <a:t>1/27/13</a:t>
+              <a:t>7/9/26</a:t>
             </a:fld>
             <a:endParaRPr lang="en-US"/>
           </a:p>
@@ -2629,10 +2626,9 @@
           <a:lstStyle/>
           <a:p>
             <a:r>
-              <a:rPr lang="en-US" smtClean="0"/>
+              <a:rPr lang="en-US"/>
               <a:t>Click to edit Master title style</a:t>
             </a:r>
-            <a:endParaRPr lang="en-US"/>
           </a:p>
         </p:txBody>
       </p:sp>
@@ -2663,38 +2659,37 @@
           <a:p>
             <a:pPr lvl="0"/>
             <a:r>
-              <a:rPr lang="en-US" smtClean="0"/>
+              <a:rPr lang="en-US"/>
               <a:t>Click to edit Master text styles</a:t>
             </a:r>
           </a:p>
           <a:p>
             <a:pPr lvl="1"/>
             <a:r>
-              <a:rPr lang="en-US" smtClean="0"/>
+              <a:rPr lang="en-US"/>
               <a:t>Second level</a:t>
             </a:r>
           </a:p>
           <a:p>
             <a:pPr lvl="2"/>
             <a:r>
-              <a:rPr lang="en-US" smtClean="0"/>
+              <a:rPr lang="en-US"/>
               <a:t>Third level</a:t>
             </a:r>
           </a:p>
           <a:p>
             <a:pPr lvl="3"/>
             <a:r>
-              <a:rPr lang="en-US" smtClean="0"/>
+              <a:rPr lang="en-US"/>
               <a:t>Fourth level</a:t>
             </a:r>
           </a:p>
           <a:p>
             <a:pPr lvl="4"/>
             <a:r>
-              <a:rPr lang="en-US" smtClean="0"/>
+              <a:rPr lang="en-US"/>
               <a:t>Fifth level</a:t>
             </a:r>
-            <a:endParaRPr lang="en-US"/>
           </a:p>
         </p:txBody>
       </p:sp>
@@ -2733,7 +2728,7 @@
           <a:p>
             <a:fld id="{5BCAD085-E8A6-8845-BD4E-CB4CCA059FC4}" type="datetimeFigureOut">
               <a:rPr lang="en-US" smtClean="0"/>
-              <a:t>1/27/13</a:t>
+              <a:t>7/9/26</a:t>
             </a:fld>
             <a:endParaRPr lang="en-US"/>
           </a:p>
@@ -3092,7 +3087,7 @@
 </file>
 
 <file path=ppt/slides/slide1.xml><?xml version="1.0" encoding="utf-8"?>
-<p:sld xmlns:a="http://schemas.openxmlformats.org/drawingml/2006/main" xmlns:p="http://schemas.openxmlformats.org/presentationml/2006/main" xmlns:r="http://schemas.openxmlformats.org/officeDocument/2006/relationships">
+<p:sld xmlns:a="http://schemas.openxmlformats.org/drawingml/2006/main" xmlns:r="http://schemas.openxmlformats.org/officeDocument/2006/relationships" xmlns:p="http://schemas.openxmlformats.org/presentationml/2006/main">
   <p:cSld>
     <p:spTree>
       <p:nvGrpSpPr>
@@ -3100,7 +3095,14 @@
         <p:cNvGrpSpPr/>
         <p:nvPr/>
       </p:nvGrpSpPr>
-      <p:grpSpPr/>
+      <p:grpSpPr>
+        <a:xfrm>
+          <a:off x="0" y="0"/>
+          <a:ext cx="0" cy="0"/>
+          <a:chOff x="0" y="0"/>
+          <a:chExt cx="0" cy="0"/>
+        </a:xfrm>
+      </p:grpSpPr>
       <p:sp>
         <p:nvSpPr>
           <p:cNvPr id="2" name="Rectangle 1"/>
@@ -3142,6 +3144,7 @@
           <a:lstStyle/>
           <a:p>
             <a:pPr algn="ctr"/>
+            <a:endParaRPr/>
           </a:p>
         </p:txBody>
       </p:sp>
@@ -3224,7 +3227,7 @@
 </file>
 
 <file path=ppt/slides/slide10.xml><?xml version="1.0" encoding="utf-8"?>
-<p:sld xmlns:a="http://schemas.openxmlformats.org/drawingml/2006/main" xmlns:p="http://schemas.openxmlformats.org/presentationml/2006/main" xmlns:r="http://schemas.openxmlformats.org/officeDocument/2006/relationships">
+<p:sld xmlns:a="http://schemas.openxmlformats.org/drawingml/2006/main" xmlns:r="http://schemas.openxmlformats.org/officeDocument/2006/relationships" xmlns:p="http://schemas.openxmlformats.org/presentationml/2006/main">
   <p:cSld>
     <p:spTree>
       <p:nvGrpSpPr>
@@ -3232,7 +3235,14 @@
         <p:cNvGrpSpPr/>
         <p:nvPr/>
       </p:nvGrpSpPr>
-      <p:grpSpPr/>
+      <p:grpSpPr>
+        <a:xfrm>
+          <a:off x="0" y="0"/>
+          <a:ext cx="0" cy="0"/>
+          <a:chOff x="0" y="0"/>
+          <a:chExt cx="0" cy="0"/>
+        </a:xfrm>
+      </p:grpSpPr>
       <p:sp>
         <p:nvSpPr>
           <p:cNvPr id="2" name="TextBox 1"/>
@@ -3263,7 +3273,7 @@
               </a:defRPr>
             </a:pPr>
             <a:r>
-              <a:t>Real vs Generated: Side by Side</a:t>
+              <a:t>Physics-Informed Diffusion (PID)</a:t>
             </a:r>
           </a:p>
         </p:txBody>
@@ -3308,6 +3318,7 @@
           <a:lstStyle/>
           <a:p>
             <a:pPr algn="ctr"/>
+            <a:endParaRPr/>
           </a:p>
         </p:txBody>
       </p:sp>
@@ -3320,7 +3331,7 @@
         <p:spPr>
           <a:xfrm>
             <a:off x="548640" y="1417320"/>
-            <a:ext cx="10972800" cy="731520"/>
+            <a:ext cx="10972800" cy="774571"/>
           </a:xfrm>
           <a:prstGeom prst="rect">
             <a:avLst/>
@@ -3337,21 +3348,38 @@
               <a:spcAft>
                 <a:spcPts val="1000"/>
               </a:spcAft>
-              <a:defRPr sz="1800">
+              <a:defRPr sz="1900">
                 <a:solidFill>
                   <a:srgbClr val="222222"/>
                 </a:solidFill>
               </a:defRPr>
             </a:pPr>
             <a:r>
-              <a:t>•  Same class (FR-I / FR-II), three sources: a real MiraBest image, a plain diffusion sample, and a PID sample</a:t>
+              <a:rPr dirty="0"/>
+              <a:t>•  Adds physics-motivated loss terms to generation:</a:t>
+            </a:r>
+          </a:p>
+          <a:p>
+            <a:pPr lvl="1">
+              <a:spcAft>
+                <a:spcPts val="1000"/>
+              </a:spcAft>
+              <a:defRPr sz="1700">
+                <a:solidFill>
+                  <a:srgbClr val="222222"/>
+                </a:solidFill>
+              </a:defRPr>
+            </a:pPr>
+            <a:r>
+              <a:rPr dirty="0"/>
+              <a:t>–  Bilateral symmetry — radio jets are approximately symmetric about the core</a:t>
             </a:r>
           </a:p>
         </p:txBody>
       </p:sp>
       <p:pic>
         <p:nvPicPr>
-          <p:cNvPr id="5" name="Picture 4" descr="true_vs_diffusion_vs_pid.png"/>
+          <p:cNvPr id="5" name="Picture 4" descr="comparison_epoch_285.png"/>
           <p:cNvPicPr>
             <a:picLocks noChangeAspect="1"/>
           </p:cNvPicPr>
@@ -3365,14 +3393,49 @@
         </p:blipFill>
         <p:spPr>
           <a:xfrm>
-            <a:off x="2701125" y="2011680"/>
-            <a:ext cx="6759269" cy="4572000"/>
+            <a:off x="2880360" y="3200400"/>
+            <a:ext cx="6400800" cy="3200400"/>
           </a:xfrm>
           <a:prstGeom prst="rect">
             <a:avLst/>
           </a:prstGeom>
         </p:spPr>
       </p:pic>
+      <p:sp>
+        <p:nvSpPr>
+          <p:cNvPr id="6" name="TextBox 5"/>
+          <p:cNvSpPr txBox="1"/>
+          <p:nvPr/>
+        </p:nvSpPr>
+        <p:spPr>
+          <a:xfrm>
+            <a:off x="2286000" y="6446520"/>
+            <a:ext cx="7589520" cy="365760"/>
+          </a:xfrm>
+          <a:prstGeom prst="rect">
+            <a:avLst/>
+          </a:prstGeom>
+          <a:noFill/>
+        </p:spPr>
+        <p:txBody>
+          <a:bodyPr wrap="none">
+            <a:spAutoFit/>
+          </a:bodyPr>
+          <a:lstStyle/>
+          <a:p>
+            <a:pPr algn="ctr">
+              <a:defRPr sz="1300" i="1">
+                <a:solidFill>
+                  <a:srgbClr val="555555"/>
+                </a:solidFill>
+              </a:defRPr>
+            </a:pPr>
+            <a:r>
+              <a:t>PID-generated samples, epoch 285 — FR-I vs FR-II</a:t>
+            </a:r>
+          </a:p>
+        </p:txBody>
+      </p:sp>
     </p:spTree>
   </p:cSld>
   <p:clrMapOvr>
@@ -3382,7 +3445,7 @@
 </file>
 
 <file path=ppt/slides/slide11.xml><?xml version="1.0" encoding="utf-8"?>
-<p:sld xmlns:a="http://schemas.openxmlformats.org/drawingml/2006/main" xmlns:p="http://schemas.openxmlformats.org/presentationml/2006/main" xmlns:r="http://schemas.openxmlformats.org/officeDocument/2006/relationships">
+<p:sld xmlns:a="http://schemas.openxmlformats.org/drawingml/2006/main" xmlns:r="http://schemas.openxmlformats.org/officeDocument/2006/relationships" xmlns:p="http://schemas.openxmlformats.org/presentationml/2006/main">
   <p:cSld>
     <p:spTree>
       <p:nvGrpSpPr>
@@ -3390,7 +3453,14 @@
         <p:cNvGrpSpPr/>
         <p:nvPr/>
       </p:nvGrpSpPr>
-      <p:grpSpPr/>
+      <p:grpSpPr>
+        <a:xfrm>
+          <a:off x="0" y="0"/>
+          <a:ext cx="0" cy="0"/>
+          <a:chOff x="0" y="0"/>
+          <a:chExt cx="0" cy="0"/>
+        </a:xfrm>
+      </p:grpSpPr>
       <p:sp>
         <p:nvSpPr>
           <p:cNvPr id="2" name="TextBox 1"/>
@@ -3421,7 +3491,7 @@
               </a:defRPr>
             </a:pPr>
             <a:r>
-              <a:t>Measuring Generation Quality: Pixel Distribution Fit</a:t>
+              <a:t>Real vs Generated: Side by Side</a:t>
             </a:r>
           </a:p>
         </p:txBody>
@@ -3466,6 +3536,7 @@
           <a:lstStyle/>
           <a:p>
             <a:pPr algn="ctr"/>
+            <a:endParaRPr/>
           </a:p>
         </p:txBody>
       </p:sp>
@@ -3478,7 +3549,7 @@
         <p:spPr>
           <a:xfrm>
             <a:off x="548640" y="1417320"/>
-            <a:ext cx="10972800" cy="2011680"/>
+            <a:ext cx="10972800" cy="731520"/>
           </a:xfrm>
           <a:prstGeom prst="rect">
             <a:avLst/>
@@ -3495,51 +3566,21 @@
               <a:spcAft>
                 <a:spcPts val="1000"/>
               </a:spcAft>
-              <a:defRPr sz="1900">
+              <a:defRPr sz="1800">
                 <a:solidFill>
                   <a:srgbClr val="222222"/>
                 </a:solidFill>
               </a:defRPr>
             </a:pPr>
             <a:r>
-              <a:t>•  Metric: Wasserstein-1 distance between the pixel-intensity distribution of real vs generated images (lower = closer match)</a:t>
-            </a:r>
-          </a:p>
-          <a:p>
-            <a:pPr>
-              <a:spcAft>
-                <a:spcPts val="1000"/>
-              </a:spcAft>
-              <a:defRPr sz="1900">
-                <a:solidFill>
-                  <a:srgbClr val="222222"/>
-                </a:solidFill>
-              </a:defRPr>
-            </a:pPr>
-            <a:r>
-              <a:t>•  Tracked every few epochs during training, per class</a:t>
-            </a:r>
-          </a:p>
-          <a:p>
-            <a:pPr>
-              <a:spcAft>
-                <a:spcPts val="1000"/>
-              </a:spcAft>
-              <a:defRPr sz="1900">
-                <a:solidFill>
-                  <a:srgbClr val="222222"/>
-                </a:solidFill>
-              </a:defRPr>
-            </a:pPr>
-            <a:r>
-              <a:t>•  Distance drops from ~0.12 (and spikes early on) down to ~0.02–0.05 by epoch 250+ — generated images increasingly match the real pixel statistics</a:t>
+              <a:t>•  Same class (FR-I / FR-II), three sources: a real MiraBest image, a plain diffusion sample, and a PID sample</a:t>
             </a:r>
           </a:p>
         </p:txBody>
       </p:sp>
       <p:pic>
         <p:nvPicPr>
-          <p:cNvPr id="5" name="Picture 4" descr="pixel_pdf_history.png"/>
+          <p:cNvPr id="5" name="Picture 4" descr="slide10_new.png"/>
           <p:cNvPicPr>
             <a:picLocks noChangeAspect="1"/>
           </p:cNvPicPr>
@@ -3553,8 +3594,8 @@
         </p:blipFill>
         <p:spPr>
           <a:xfrm>
-            <a:off x="3154680" y="3291840"/>
-            <a:ext cx="5852160" cy="3657600"/>
+            <a:off x="2701125" y="2011680"/>
+            <a:ext cx="6759269" cy="4572000"/>
           </a:xfrm>
           <a:prstGeom prst="rect">
             <a:avLst/>
@@ -3570,7 +3611,7 @@
 </file>
 
 <file path=ppt/slides/slide12.xml><?xml version="1.0" encoding="utf-8"?>
-<p:sld xmlns:a="http://schemas.openxmlformats.org/drawingml/2006/main" xmlns:p="http://schemas.openxmlformats.org/presentationml/2006/main" xmlns:r="http://schemas.openxmlformats.org/officeDocument/2006/relationships">
+<p:sld xmlns:a="http://schemas.openxmlformats.org/drawingml/2006/main" xmlns:r="http://schemas.openxmlformats.org/officeDocument/2006/relationships" xmlns:p="http://schemas.openxmlformats.org/presentationml/2006/main">
   <p:cSld>
     <p:spTree>
       <p:nvGrpSpPr>
@@ -3578,7 +3619,14 @@
         <p:cNvGrpSpPr/>
         <p:nvPr/>
       </p:nvGrpSpPr>
-      <p:grpSpPr/>
+      <p:grpSpPr>
+        <a:xfrm>
+          <a:off x="0" y="0"/>
+          <a:ext cx="0" cy="0"/>
+          <a:chOff x="0" y="0"/>
+          <a:chExt cx="0" cy="0"/>
+        </a:xfrm>
+      </p:grpSpPr>
       <p:sp>
         <p:nvSpPr>
           <p:cNvPr id="2" name="TextBox 1"/>
@@ -3609,7 +3657,7 @@
               </a:defRPr>
             </a:pPr>
             <a:r>
-              <a:t>Summary of Progress</a:t>
+              <a:t>Measuring Generation Quality: Pixel Distribution Fit</a:t>
             </a:r>
           </a:p>
         </p:txBody>
@@ -3654,6 +3702,7 @@
           <a:lstStyle/>
           <a:p>
             <a:pPr algn="ctr"/>
+            <a:endParaRPr/>
           </a:p>
         </p:txBody>
       </p:sp>
@@ -3666,7 +3715,7 @@
         <p:spPr>
           <a:xfrm>
             <a:off x="548640" y="1417320"/>
-            <a:ext cx="10972800" cy="4846320"/>
+            <a:ext cx="10972800" cy="2011680"/>
           </a:xfrm>
           <a:prstGeom prst="rect">
             <a:avLst/>
@@ -3683,14 +3732,14 @@
               <a:spcAft>
                 <a:spcPts val="1000"/>
               </a:spcAft>
-              <a:defRPr sz="2200">
+              <a:defRPr sz="1900">
                 <a:solidFill>
                   <a:srgbClr val="222222"/>
                 </a:solidFill>
               </a:defRPr>
             </a:pPr>
             <a:r>
-              <a:t>•  Working FR-I/FR-II classifier: ~90% on MiraBest</a:t>
+              <a:t>•  Metric: Wasserstein-1 distance between the pixel-intensity distribution of real vs generated images (lower = closer match)</a:t>
             </a:r>
           </a:p>
           <a:p>
@@ -3698,14 +3747,14 @@
               <a:spcAft>
                 <a:spcPts val="1000"/>
               </a:spcAft>
-              <a:defRPr sz="2200">
+              <a:defRPr sz="1900">
                 <a:solidFill>
                   <a:srgbClr val="222222"/>
                 </a:solidFill>
               </a:defRPr>
             </a:pPr>
             <a:r>
-              <a:t>•  Fixed two real bugs this week: overfitting-prone architecture, and a checkpoint/best-epoch mismatch</a:t>
+              <a:t>•  Tracked every few epochs during training, per class</a:t>
             </a:r>
           </a:p>
           <a:p>
@@ -3713,18 +3762,42 @@
               <a:spcAft>
                 <a:spcPts val="1000"/>
               </a:spcAft>
-              <a:defRPr sz="2200">
+              <a:defRPr sz="1900">
                 <a:solidFill>
                   <a:srgbClr val="222222"/>
                 </a:solidFill>
               </a:defRPr>
             </a:pPr>
             <a:r>
-              <a:t>•  Working class-conditional diffusion generation, now with physics-informed constraints (PID)</a:t>
-            </a:r>
-          </a:p>
-        </p:txBody>
-      </p:sp>
+              <a:t>•  Distance drops from ~0.12 (and spikes early on) down to ~0.02–0.05 by epoch 250+ — generated images increasingly match the real pixel statistics</a:t>
+            </a:r>
+          </a:p>
+        </p:txBody>
+      </p:sp>
+      <p:pic>
+        <p:nvPicPr>
+          <p:cNvPr id="5" name="Picture 4" descr="pixel_pdf_history.png"/>
+          <p:cNvPicPr>
+            <a:picLocks noChangeAspect="1"/>
+          </p:cNvPicPr>
+          <p:nvPr/>
+        </p:nvPicPr>
+        <p:blipFill>
+          <a:blip r:embed="rId2"/>
+          <a:stretch>
+            <a:fillRect/>
+          </a:stretch>
+        </p:blipFill>
+        <p:spPr>
+          <a:xfrm>
+            <a:off x="3154680" y="3291840"/>
+            <a:ext cx="5852160" cy="3657600"/>
+          </a:xfrm>
+          <a:prstGeom prst="rect">
+            <a:avLst/>
+          </a:prstGeom>
+        </p:spPr>
+      </p:pic>
     </p:spTree>
   </p:cSld>
   <p:clrMapOvr>
@@ -3734,7 +3807,7 @@
 </file>
 
 <file path=ppt/slides/slide13.xml><?xml version="1.0" encoding="utf-8"?>
-<p:sld xmlns:a="http://schemas.openxmlformats.org/drawingml/2006/main" xmlns:p="http://schemas.openxmlformats.org/presentationml/2006/main" xmlns:r="http://schemas.openxmlformats.org/officeDocument/2006/relationships">
+<p:sld xmlns:a="http://schemas.openxmlformats.org/drawingml/2006/main" xmlns:r="http://schemas.openxmlformats.org/officeDocument/2006/relationships" xmlns:p="http://schemas.openxmlformats.org/presentationml/2006/main">
   <p:cSld>
     <p:spTree>
       <p:nvGrpSpPr>
@@ -3742,7 +3815,14 @@
         <p:cNvGrpSpPr/>
         <p:nvPr/>
       </p:nvGrpSpPr>
-      <p:grpSpPr/>
+      <p:grpSpPr>
+        <a:xfrm>
+          <a:off x="0" y="0"/>
+          <a:ext cx="0" cy="0"/>
+          <a:chOff x="0" y="0"/>
+          <a:chExt cx="0" cy="0"/>
+        </a:xfrm>
+      </p:grpSpPr>
       <p:sp>
         <p:nvSpPr>
           <p:cNvPr id="2" name="TextBox 1"/>
@@ -3818,6 +3898,7 @@
           <a:lstStyle/>
           <a:p>
             <a:pPr algn="ctr"/>
+            <a:endParaRPr/>
           </a:p>
         </p:txBody>
       </p:sp>
@@ -3830,7 +3911,7 @@
         <p:spPr>
           <a:xfrm>
             <a:off x="548640" y="1417320"/>
-            <a:ext cx="10972800" cy="4846320"/>
+            <a:ext cx="10972800" cy="1887696"/>
           </a:xfrm>
           <a:prstGeom prst="rect">
             <a:avLst/>
@@ -3854,7 +3935,8 @@
               </a:defRPr>
             </a:pPr>
             <a:r>
-              <a:t>•  Grow the training dataset with more labeled radio galaxy images</a:t>
+              <a:rPr dirty="0"/>
+              <a:t>•  Wire up the robust classifier + guided-diffusion pipeline (currently not connected to the training dispatcher)</a:t>
             </a:r>
           </a:p>
           <a:p>
@@ -3869,7 +3951,8 @@
               </a:defRPr>
             </a:pPr>
             <a:r>
-              <a:t>•  Wire up the robust classifier + guided-diffusion pipeline (currently not connected to the training dispatcher)</a:t>
+              <a:rPr dirty="0"/>
+              <a:t>•  Try a VAE to encode and reconstruct images — test whether it preserves the real pixel/morphology distribution as well as diffusion does</a:t>
             </a:r>
           </a:p>
           <a:p>
@@ -3884,21 +3967,7 @@
               </a:defRPr>
             </a:pPr>
             <a:r>
-              <a:t>•  Try a VAE to encode and reconstruct images — test whether it preserves the real pixel/morphology distribution as well as diffusion does</a:t>
-            </a:r>
-          </a:p>
-          <a:p>
-            <a:pPr>
-              <a:spcAft>
-                <a:spcPts val="1000"/>
-              </a:spcAft>
-              <a:defRPr sz="2000">
-                <a:solidFill>
-                  <a:srgbClr val="222222"/>
-                </a:solidFill>
-              </a:defRPr>
-            </a:pPr>
-            <a:r>
+              <a:rPr dirty="0"/>
               <a:t>•  Implement a classifier-confidence-based image-quality metric for generated samples</a:t>
             </a:r>
           </a:p>
@@ -3913,7 +3982,7 @@
 </file>
 
 <file path=ppt/slides/slide14.xml><?xml version="1.0" encoding="utf-8"?>
-<p:sld xmlns:a="http://schemas.openxmlformats.org/drawingml/2006/main" xmlns:p="http://schemas.openxmlformats.org/presentationml/2006/main" xmlns:r="http://schemas.openxmlformats.org/officeDocument/2006/relationships">
+<p:sld xmlns:a="http://schemas.openxmlformats.org/drawingml/2006/main" xmlns:r="http://schemas.openxmlformats.org/officeDocument/2006/relationships" xmlns:p="http://schemas.openxmlformats.org/presentationml/2006/main">
   <p:cSld>
     <p:spTree>
       <p:nvGrpSpPr>
@@ -3921,7 +3990,14 @@
         <p:cNvGrpSpPr/>
         <p:nvPr/>
       </p:nvGrpSpPr>
-      <p:grpSpPr/>
+      <p:grpSpPr>
+        <a:xfrm>
+          <a:off x="0" y="0"/>
+          <a:ext cx="0" cy="0"/>
+          <a:chOff x="0" y="0"/>
+          <a:chExt cx="0" cy="0"/>
+        </a:xfrm>
+      </p:grpSpPr>
       <p:sp>
         <p:nvSpPr>
           <p:cNvPr id="2" name="Rectangle 1"/>
@@ -3963,6 +4039,7 @@
           <a:lstStyle/>
           <a:p>
             <a:pPr algn="ctr"/>
+            <a:endParaRPr/>
           </a:p>
         </p:txBody>
       </p:sp>
@@ -4010,7 +4087,7 @@
 </file>
 
 <file path=ppt/slides/slide2.xml><?xml version="1.0" encoding="utf-8"?>
-<p:sld xmlns:a="http://schemas.openxmlformats.org/drawingml/2006/main" xmlns:p="http://schemas.openxmlformats.org/presentationml/2006/main" xmlns:r="http://schemas.openxmlformats.org/officeDocument/2006/relationships">
+<p:sld xmlns:a="http://schemas.openxmlformats.org/drawingml/2006/main" xmlns:r="http://schemas.openxmlformats.org/officeDocument/2006/relationships" xmlns:p="http://schemas.openxmlformats.org/presentationml/2006/main">
   <p:cSld>
     <p:spTree>
       <p:nvGrpSpPr>
@@ -4018,7 +4095,14 @@
         <p:cNvGrpSpPr/>
         <p:nvPr/>
       </p:nvGrpSpPr>
-      <p:grpSpPr/>
+      <p:grpSpPr>
+        <a:xfrm>
+          <a:off x="0" y="0"/>
+          <a:ext cx="0" cy="0"/>
+          <a:chOff x="0" y="0"/>
+          <a:chExt cx="0" cy="0"/>
+        </a:xfrm>
+      </p:grpSpPr>
       <p:sp>
         <p:nvSpPr>
           <p:cNvPr id="2" name="TextBox 1"/>
@@ -4094,6 +4178,7 @@
           <a:lstStyle/>
           <a:p>
             <a:pPr algn="ctr"/>
+            <a:endParaRPr/>
           </a:p>
         </p:txBody>
       </p:sp>
@@ -4106,7 +4191,7 @@
         <p:spPr>
           <a:xfrm>
             <a:off x="548640" y="1417320"/>
-            <a:ext cx="10972800" cy="4846320"/>
+            <a:ext cx="10972800" cy="1451679"/>
           </a:xfrm>
           <a:prstGeom prst="rect">
             <a:avLst/>
@@ -4130,37 +4215,16 @@
               </a:defRPr>
             </a:pPr>
             <a:r>
-              <a:t>•  Fanaroff-Riley classification (FR-I / FR-II) separates radio galaxies by jet structure:</a:t>
-            </a:r>
-          </a:p>
-          <a:p>
-            <a:pPr lvl="1">
-              <a:spcAft>
-                <a:spcPts val="1000"/>
-              </a:spcAft>
-              <a:defRPr sz="1800">
-                <a:solidFill>
-                  <a:srgbClr val="222222"/>
-                </a:solidFill>
-              </a:defRPr>
-            </a:pPr>
-            <a:r>
-              <a:t>–  FR-I — edge-darkened, jets fade with distance from the core</a:t>
-            </a:r>
-          </a:p>
-          <a:p>
-            <a:pPr lvl="1">
-              <a:spcAft>
-                <a:spcPts val="1000"/>
-              </a:spcAft>
-              <a:defRPr sz="1800">
-                <a:solidFill>
-                  <a:srgbClr val="222222"/>
-                </a:solidFill>
-              </a:defRPr>
-            </a:pPr>
-            <a:r>
-              <a:t>–  FR-II — edge-brightened, jets stay narrow all the way out to bright hotspots</a:t>
+              <a:rPr dirty="0"/>
+              <a:t>•  Modern/upcoming surveys (</a:t>
+            </a:r>
+            <a:r>
+              <a:rPr dirty="0" err="1"/>
+              <a:t>MeerKAT</a:t>
+            </a:r>
+            <a:r>
+              <a:rPr dirty="0"/>
+              <a:t>, SKA) will produce far more radio sources than can be classified by hand</a:t>
             </a:r>
           </a:p>
           <a:p>
@@ -4175,38 +4239,22 @@
               </a:defRPr>
             </a:pPr>
             <a:r>
-              <a:t>•  The FR dichotomy is tied to jet power and AGN feedback physics — a key observable for galaxy evolution models</a:t>
-            </a:r>
-          </a:p>
-          <a:p>
-            <a:pPr>
-              <a:spcAft>
-                <a:spcPts val="1000"/>
-              </a:spcAft>
-              <a:defRPr sz="2000">
-                <a:solidFill>
-                  <a:srgbClr val="222222"/>
-                </a:solidFill>
-              </a:defRPr>
-            </a:pPr>
-            <a:r>
-              <a:t>•  Modern/upcoming surveys (MeerKAT, SKA) will produce far more radio sources than can be classified by hand</a:t>
-            </a:r>
-          </a:p>
-          <a:p>
-            <a:pPr>
-              <a:spcAft>
-                <a:spcPts val="1000"/>
-              </a:spcAft>
-              <a:defRPr sz="2000">
-                <a:solidFill>
-                  <a:srgbClr val="222222"/>
-                </a:solidFill>
-              </a:defRPr>
-            </a:pPr>
-            <a:r>
-              <a:t>•  Motivates: (1) automated classification, (2) generative models to augment scarce, expensive labeled data</a:t>
-            </a:r>
+              <a:rPr dirty="0"/>
+              <a:t>•  Motivates: (1) automated classification, (2) generative models to augment scarce</a:t>
+            </a:r>
+            <a:r>
+              <a:rPr lang="en-US" dirty="0"/>
+              <a:t> </a:t>
+            </a:r>
+            <a:r>
+              <a:rPr dirty="0"/>
+              <a:t>data</a:t>
+            </a:r>
+            <a:r>
+              <a:rPr lang="en-US" dirty="0"/>
+              <a:t> to counter under-representation of entities in downstream machine learning tasks.</a:t>
+            </a:r>
+            <a:endParaRPr dirty="0"/>
           </a:p>
         </p:txBody>
       </p:sp>
@@ -4219,7 +4267,7 @@
 </file>
 
 <file path=ppt/slides/slide3.xml><?xml version="1.0" encoding="utf-8"?>
-<p:sld xmlns:a="http://schemas.openxmlformats.org/drawingml/2006/main" xmlns:p="http://schemas.openxmlformats.org/presentationml/2006/main" xmlns:r="http://schemas.openxmlformats.org/officeDocument/2006/relationships">
+<p:sld xmlns:a="http://schemas.openxmlformats.org/drawingml/2006/main" xmlns:r="http://schemas.openxmlformats.org/officeDocument/2006/relationships" xmlns:p="http://schemas.openxmlformats.org/presentationml/2006/main">
   <p:cSld>
     <p:spTree>
       <p:nvGrpSpPr>
@@ -4227,7 +4275,14 @@
         <p:cNvGrpSpPr/>
         <p:nvPr/>
       </p:nvGrpSpPr>
-      <p:grpSpPr/>
+      <p:grpSpPr>
+        <a:xfrm>
+          <a:off x="0" y="0"/>
+          <a:ext cx="0" cy="0"/>
+          <a:chOff x="0" y="0"/>
+          <a:chExt cx="0" cy="0"/>
+        </a:xfrm>
+      </p:grpSpPr>
       <p:sp>
         <p:nvSpPr>
           <p:cNvPr id="2" name="TextBox 1"/>
@@ -4303,6 +4358,7 @@
           <a:lstStyle/>
           <a:p>
             <a:pPr algn="ctr"/>
+            <a:endParaRPr/>
           </a:p>
         </p:txBody>
       </p:sp>
@@ -4315,7 +4371,7 @@
         <p:spPr>
           <a:xfrm>
             <a:off x="548640" y="1417320"/>
-            <a:ext cx="5303520" cy="2743200"/>
+            <a:ext cx="5303520" cy="1051570"/>
           </a:xfrm>
           <a:prstGeom prst="rect">
             <a:avLst/>
@@ -4339,8 +4395,18 @@
               </a:defRPr>
             </a:pPr>
             <a:r>
-              <a:t>•  MiraBest — single homogeneous survey, expert-vetted, ~770 images</a:t>
-            </a:r>
+              <a:rPr dirty="0"/>
+              <a:t>•  </a:t>
+            </a:r>
+            <a:r>
+              <a:rPr dirty="0" err="1"/>
+              <a:t>MiraBest</a:t>
+            </a:r>
+            <a:r>
+              <a:rPr dirty="0"/>
+              <a:t> — single homogeneous survey, expert-vetted, ~770 images</a:t>
+            </a:r>
+            <a:endParaRPr lang="en-US" dirty="0"/>
           </a:p>
           <a:p>
             <a:pPr>
@@ -4354,14 +4420,85 @@
               </a:defRPr>
             </a:pPr>
             <a:r>
-              <a:t>•  Binary FR-I / FR-II labels, 150×150 grayscale postage stamps</a:t>
+              <a:rPr lang="en-ZA" dirty="0"/>
+              <a:t>•  Binary FR-I / FR-II labels, 150×150 grayscale</a:t>
+            </a:r>
+          </a:p>
+        </p:txBody>
+      </p:sp>
+      <p:sp>
+        <p:nvSpPr>
+          <p:cNvPr id="7" name="TextBox 6"/>
+          <p:cNvSpPr txBox="1"/>
+          <p:nvPr/>
+        </p:nvSpPr>
+        <p:spPr>
+          <a:xfrm>
+            <a:off x="6035040" y="4251960"/>
+            <a:ext cx="2743200" cy="365760"/>
+          </a:xfrm>
+          <a:prstGeom prst="rect">
+            <a:avLst/>
+          </a:prstGeom>
+          <a:noFill/>
+        </p:spPr>
+        <p:txBody>
+          <a:bodyPr wrap="none">
+            <a:spAutoFit/>
+          </a:bodyPr>
+          <a:lstStyle/>
+          <a:p>
+            <a:pPr algn="ctr">
+              <a:defRPr sz="1300" i="1">
+                <a:solidFill>
+                  <a:srgbClr val="555555"/>
+                </a:solidFill>
+              </a:defRPr>
+            </a:pPr>
+            <a:r>
+              <a:t>FR-I examples</a:t>
+            </a:r>
+          </a:p>
+        </p:txBody>
+      </p:sp>
+      <p:sp>
+        <p:nvSpPr>
+          <p:cNvPr id="8" name="TextBox 7"/>
+          <p:cNvSpPr txBox="1"/>
+          <p:nvPr/>
+        </p:nvSpPr>
+        <p:spPr>
+          <a:xfrm>
+            <a:off x="8869680" y="4251960"/>
+            <a:ext cx="2743200" cy="365760"/>
+          </a:xfrm>
+          <a:prstGeom prst="rect">
+            <a:avLst/>
+          </a:prstGeom>
+          <a:noFill/>
+        </p:spPr>
+        <p:txBody>
+          <a:bodyPr wrap="none">
+            <a:spAutoFit/>
+          </a:bodyPr>
+          <a:lstStyle/>
+          <a:p>
+            <a:pPr algn="ctr">
+              <a:defRPr sz="1300" i="1">
+                <a:solidFill>
+                  <a:srgbClr val="555555"/>
+                </a:solidFill>
+              </a:defRPr>
+            </a:pPr>
+            <a:r>
+              <a:t>FR-II examples</a:t>
             </a:r>
           </a:p>
         </p:txBody>
       </p:sp>
       <p:pic>
         <p:nvPicPr>
-          <p:cNvPr id="5" name="Picture 4" descr="mirabest_true_fri_grid.png"/>
+          <p:cNvPr id="9" name="Picture 8" descr="mirabest_true_fri_grid.png"/>
           <p:cNvPicPr>
             <a:picLocks noChangeAspect="1"/>
           </p:cNvPicPr>
@@ -4385,7 +4522,7 @@
       </p:pic>
       <p:pic>
         <p:nvPicPr>
-          <p:cNvPr id="6" name="Picture 5" descr="mirabest_true_frii_grid.png"/>
+          <p:cNvPr id="10" name="Picture 9" descr="mirabest_true_frii_grid.png"/>
           <p:cNvPicPr>
             <a:picLocks noChangeAspect="1"/>
           </p:cNvPicPr>
@@ -4407,76 +4544,6 @@
           </a:prstGeom>
         </p:spPr>
       </p:pic>
-      <p:sp>
-        <p:nvSpPr>
-          <p:cNvPr id="7" name="TextBox 6"/>
-          <p:cNvSpPr txBox="1"/>
-          <p:nvPr/>
-        </p:nvSpPr>
-        <p:spPr>
-          <a:xfrm>
-            <a:off x="6035040" y="4251960"/>
-            <a:ext cx="2743200" cy="365760"/>
-          </a:xfrm>
-          <a:prstGeom prst="rect">
-            <a:avLst/>
-          </a:prstGeom>
-          <a:noFill/>
-        </p:spPr>
-        <p:txBody>
-          <a:bodyPr wrap="none">
-            <a:spAutoFit/>
-          </a:bodyPr>
-          <a:lstStyle/>
-          <a:p>
-            <a:pPr algn="ctr">
-              <a:defRPr sz="1300" i="1">
-                <a:solidFill>
-                  <a:srgbClr val="555555"/>
-                </a:solidFill>
-              </a:defRPr>
-            </a:pPr>
-            <a:r>
-              <a:t>FR-I examples</a:t>
-            </a:r>
-          </a:p>
-        </p:txBody>
-      </p:sp>
-      <p:sp>
-        <p:nvSpPr>
-          <p:cNvPr id="8" name="TextBox 7"/>
-          <p:cNvSpPr txBox="1"/>
-          <p:nvPr/>
-        </p:nvSpPr>
-        <p:spPr>
-          <a:xfrm>
-            <a:off x="8869680" y="4251960"/>
-            <a:ext cx="2743200" cy="365760"/>
-          </a:xfrm>
-          <a:prstGeom prst="rect">
-            <a:avLst/>
-          </a:prstGeom>
-          <a:noFill/>
-        </p:spPr>
-        <p:txBody>
-          <a:bodyPr wrap="none">
-            <a:spAutoFit/>
-          </a:bodyPr>
-          <a:lstStyle/>
-          <a:p>
-            <a:pPr algn="ctr">
-              <a:defRPr sz="1300" i="1">
-                <a:solidFill>
-                  <a:srgbClr val="555555"/>
-                </a:solidFill>
-              </a:defRPr>
-            </a:pPr>
-            <a:r>
-              <a:t>FR-II examples</a:t>
-            </a:r>
-          </a:p>
-        </p:txBody>
-      </p:sp>
     </p:spTree>
   </p:cSld>
   <p:clrMapOvr>
@@ -4486,25 +4553,44 @@
 </file>
 
 <file path=ppt/slides/slide4.xml><?xml version="1.0" encoding="utf-8"?>
-<p:sld xmlns:a="http://schemas.openxmlformats.org/drawingml/2006/main" xmlns:p="http://schemas.openxmlformats.org/presentationml/2006/main" xmlns:r="http://schemas.openxmlformats.org/officeDocument/2006/relationships">
+<p:sld xmlns:a="http://schemas.openxmlformats.org/drawingml/2006/main" xmlns:r="http://schemas.openxmlformats.org/officeDocument/2006/relationships" xmlns:p="http://schemas.openxmlformats.org/presentationml/2006/main">
   <p:cSld>
     <p:spTree>
       <p:nvGrpSpPr>
-        <p:cNvPr id="1" name=""/>
+        <p:cNvPr id="1" name="">
+          <a:extLst>
+            <a:ext uri="{FF2B5EF4-FFF2-40B4-BE49-F238E27FC236}">
+              <a16:creationId xmlns:a16="http://schemas.microsoft.com/office/drawing/2014/main" id="{408C1ADC-2AF2-1601-A441-BF4F1979A5BA}"/>
+            </a:ext>
+          </a:extLst>
+        </p:cNvPr>
         <p:cNvGrpSpPr/>
         <p:nvPr/>
       </p:nvGrpSpPr>
-      <p:grpSpPr/>
-      <p:sp>
-        <p:nvSpPr>
-          <p:cNvPr id="2" name="TextBox 1"/>
+      <p:grpSpPr>
+        <a:xfrm>
+          <a:off x="0" y="0"/>
+          <a:ext cx="0" cy="0"/>
+          <a:chOff x="0" y="0"/>
+          <a:chExt cx="0" cy="0"/>
+        </a:xfrm>
+      </p:grpSpPr>
+      <p:sp>
+        <p:nvSpPr>
+          <p:cNvPr id="2" name="TextBox 1">
+            <a:extLst>
+              <a:ext uri="{FF2B5EF4-FFF2-40B4-BE49-F238E27FC236}">
+                <a16:creationId xmlns:a16="http://schemas.microsoft.com/office/drawing/2014/main" id="{7E35F0FE-65F4-1C8C-5492-4B03002E5621}"/>
+              </a:ext>
+            </a:extLst>
+          </p:cNvPr>
           <p:cNvSpPr txBox="1"/>
           <p:nvPr/>
         </p:nvSpPr>
         <p:spPr>
           <a:xfrm>
             <a:off x="548640" y="320040"/>
-            <a:ext cx="11094415" cy="914400"/>
+            <a:ext cx="11094415" cy="646331"/>
           </a:xfrm>
           <a:prstGeom prst="rect">
             <a:avLst/>
@@ -4525,14 +4611,22 @@
               </a:defRPr>
             </a:pPr>
             <a:r>
-              <a:t>Project Architecture</a:t>
-            </a:r>
-          </a:p>
-        </p:txBody>
-      </p:sp>
-      <p:sp>
-        <p:nvSpPr>
-          <p:cNvPr id="3" name="Rectangle 2"/>
+              <a:rPr lang="en-US" dirty="0"/>
+              <a:t>Image Generation with Diffusion</a:t>
+            </a:r>
+            <a:endParaRPr dirty="0"/>
+          </a:p>
+        </p:txBody>
+      </p:sp>
+      <p:sp>
+        <p:nvSpPr>
+          <p:cNvPr id="3" name="Rectangle 2">
+            <a:extLst>
+              <a:ext uri="{FF2B5EF4-FFF2-40B4-BE49-F238E27FC236}">
+                <a16:creationId xmlns:a16="http://schemas.microsoft.com/office/drawing/2014/main" id="{537EC5A7-80C9-DCA8-DF70-BF65C5103F62}"/>
+              </a:ext>
+            </a:extLst>
+          </p:cNvPr>
           <p:cNvSpPr/>
           <p:nvPr/>
         </p:nvSpPr>
@@ -4570,6 +4664,7 @@
           <a:lstStyle/>
           <a:p>
             <a:pPr algn="ctr"/>
+            <a:endParaRPr/>
           </a:p>
         </p:txBody>
       </p:sp>
@@ -4582,7 +4677,7 @@
         <p:spPr>
           <a:xfrm>
             <a:off x="548640" y="1417320"/>
-            <a:ext cx="10972800" cy="4846320"/>
+            <a:ext cx="10972800" cy="700000"/>
           </a:xfrm>
           <a:prstGeom prst="rect">
             <a:avLst/>
@@ -4595,140 +4690,50 @@
           </a:bodyPr>
           <a:lstStyle/>
           <a:p>
-            <a:pPr>
-              <a:spcAft>
-                <a:spcPts val="1000"/>
-              </a:spcAft>
-              <a:defRPr sz="2200">
+            <a:r>
+              <a:rPr sz="1800">
                 <a:solidFill>
                   <a:srgbClr val="222222"/>
                 </a:solidFill>
-              </a:defRPr>
-            </a:pPr>
-            <a:r>
-              <a:t>•  1. Classifier — ResNet18, distinguishes FR-I / FR-II</a:t>
-            </a:r>
-          </a:p>
-          <a:p>
-            <a:pPr>
-              <a:spcAft>
-                <a:spcPts val="1000"/>
-              </a:spcAft>
-              <a:defRPr sz="2200">
+              </a:rPr>
+              <a:t>• Forward process gradually adds Gaussian noise to a real image over T steps (fixed, not learned)</a:t>
+            </a:r>
+          </a:p>
+          <a:p>
+            <a:r>
+              <a:rPr sz="1800">
                 <a:solidFill>
                   <a:srgbClr val="222222"/>
                 </a:solidFill>
-              </a:defRPr>
-            </a:pPr>
-            <a:r>
-              <a:t>•  2. Classifier-guided diffusion — class-conditional UNet + DDPM generates synthetic radio galaxies, steered by classifier feedback</a:t>
-            </a:r>
-          </a:p>
-          <a:p>
-            <a:pPr>
-              <a:spcAft>
-                <a:spcPts val="1000"/>
-              </a:spcAft>
-              <a:defRPr sz="2200">
-                <a:solidFill>
-                  <a:srgbClr val="222222"/>
-                </a:solidFill>
-              </a:defRPr>
-            </a:pPr>
-            <a:r>
-              <a:t>•  3. Physics-informed constraints — bilateral symmetry + non-negative flux losses, grounded in AGN jet physics</a:t>
-            </a:r>
-          </a:p>
-          <a:p>
-            <a:pPr>
-              <a:spcAft>
-                <a:spcPts val="1000"/>
-              </a:spcAft>
-              <a:defRPr sz="2200">
-                <a:solidFill>
-                  <a:srgbClr val="222222"/>
-                </a:solidFill>
-              </a:defRPr>
-            </a:pPr>
-            <a:r>
-              <a:t>•  Goal: generate physically-plausible, class-faithful synthetic radio galaxies to augment scarce labeled data</a:t>
-            </a:r>
-          </a:p>
-        </p:txBody>
-      </p:sp>
-    </p:spTree>
-  </p:cSld>
-  <p:clrMapOvr>
-    <a:masterClrMapping/>
-  </p:clrMapOvr>
-</p:sld>
-</file>
-
-<file path=ppt/slides/slide5.xml><?xml version="1.0" encoding="utf-8"?>
-<p:sld xmlns:a="http://schemas.openxmlformats.org/drawingml/2006/main" xmlns:p="http://schemas.openxmlformats.org/presentationml/2006/main" xmlns:r="http://schemas.openxmlformats.org/officeDocument/2006/relationships">
-  <p:cSld>
-    <p:spTree>
-      <p:nvGrpSpPr>
-        <p:cNvPr id="1" name=""/>
-        <p:cNvGrpSpPr/>
-        <p:nvPr/>
-      </p:nvGrpSpPr>
-      <p:grpSpPr/>
-      <p:sp>
-        <p:nvSpPr>
-          <p:cNvPr id="2" name="TextBox 1"/>
-          <p:cNvSpPr txBox="1"/>
-          <p:nvPr/>
-        </p:nvSpPr>
-        <p:spPr>
-          <a:xfrm>
-            <a:off x="548640" y="320040"/>
-            <a:ext cx="11094415" cy="914400"/>
-          </a:xfrm>
-          <a:prstGeom prst="rect">
-            <a:avLst/>
-          </a:prstGeom>
-          <a:noFill/>
-        </p:spPr>
-        <p:txBody>
-          <a:bodyPr wrap="square">
-            <a:spAutoFit/>
-          </a:bodyPr>
-          <a:lstStyle/>
-          <a:p>
-            <a:pPr>
-              <a:defRPr sz="3600" b="1">
-                <a:solidFill>
-                  <a:srgbClr val="1B2A4A"/>
-                </a:solidFill>
-              </a:defRPr>
-            </a:pPr>
-            <a:r>
-              <a:t>Classification Results</a:t>
-            </a:r>
-          </a:p>
-        </p:txBody>
-      </p:sp>
-      <p:sp>
-        <p:nvSpPr>
-          <p:cNvPr id="3" name="Rectangle 2"/>
+              </a:rPr>
+              <a:t>• Reverse process learns to remove noise step by step, turning pure noise back into an image</a:t>
+            </a:r>
+          </a:p>
+        </p:txBody>
+      </p:sp>
+      <p:sp>
+        <p:nvSpPr>
+          <p:cNvPr id="5" name="Rounded Rectangle 4"/>
           <p:cNvSpPr/>
           <p:nvPr/>
         </p:nvSpPr>
         <p:spPr>
           <a:xfrm>
-            <a:off x="548640" y="1143000"/>
-            <a:ext cx="2011680" cy="38100"/>
-          </a:xfrm>
-          <a:prstGeom prst="rect">
+            <a:off x="800000" y="2700000"/>
+            <a:ext cx="1500000" cy="1400000"/>
+          </a:xfrm>
+          <a:prstGeom prst="roundRect">
             <a:avLst/>
           </a:prstGeom>
           <a:solidFill>
             <a:srgbClr val="2E86C1"/>
           </a:solidFill>
-          <a:ln>
-            <a:noFill/>
+          <a:ln w="12700">
+            <a:solidFill>
+              <a:srgbClr val="1B2A4A"/>
+            </a:solidFill>
           </a:ln>
+          <a:effectLst/>
         </p:spPr>
         <p:style>
           <a:lnRef idx="1">
@@ -4749,19 +4754,20 @@
           <a:lstStyle/>
           <a:p>
             <a:pPr algn="ctr"/>
-          </a:p>
-        </p:txBody>
-      </p:sp>
-      <p:sp>
-        <p:nvSpPr>
-          <p:cNvPr id="4" name="TextBox 3"/>
+            <a:endParaRPr/>
+          </a:p>
+        </p:txBody>
+      </p:sp>
+      <p:sp>
+        <p:nvSpPr>
+          <p:cNvPr id="6" name="TextBox 5"/>
           <p:cNvSpPr txBox="1"/>
           <p:nvPr/>
         </p:nvSpPr>
         <p:spPr>
           <a:xfrm>
-            <a:off x="548640" y="1417320"/>
-            <a:ext cx="5120640" cy="2743200"/>
+            <a:off x="800000" y="4160000"/>
+            <a:ext cx="1500000" cy="400000"/>
           </a:xfrm>
           <a:prstGeom prst="rect">
             <a:avLst/>
@@ -4774,169 +4780,42 @@
           </a:bodyPr>
           <a:lstStyle/>
           <a:p>
-            <a:pPr>
-              <a:spcAft>
-                <a:spcPts val="1000"/>
-              </a:spcAft>
-              <a:defRPr sz="2000">
+            <a:pPr algn="ctr"/>
+            <a:r>
+              <a:rPr sz="1600" b="1">
                 <a:solidFill>
                   <a:srgbClr val="222222"/>
                 </a:solidFill>
-              </a:defRPr>
-            </a:pPr>
-            <a:r>
-              <a:t>•  MiraBest: ~90% test accuracy, consistent across multiple runs (88–94%)</a:t>
-            </a:r>
-          </a:p>
-          <a:p>
-            <a:pPr>
-              <a:spcAft>
-                <a:spcPts val="1000"/>
-              </a:spcAft>
-              <a:defRPr sz="2000">
-                <a:solidFill>
-                  <a:srgbClr val="222222"/>
-                </a:solidFill>
-              </a:defRPr>
-            </a:pPr>
-            <a:r>
-              <a:t>•  Independently verified: a random-sample check of the saved model got 90/100 correct</a:t>
-            </a:r>
-          </a:p>
-        </p:txBody>
-      </p:sp>
-      <p:pic>
-        <p:nvPicPr>
-          <p:cNvPr id="5" name="Picture 4" descr="confusion_matrix.png"/>
-          <p:cNvPicPr>
-            <a:picLocks noChangeAspect="1"/>
-          </p:cNvPicPr>
-          <p:nvPr/>
-        </p:nvPicPr>
-        <p:blipFill>
-          <a:blip r:embed="rId2"/>
-          <a:stretch>
-            <a:fillRect/>
-          </a:stretch>
-        </p:blipFill>
-        <p:spPr>
-          <a:xfrm>
-            <a:off x="6035040" y="1748790"/>
-            <a:ext cx="5577840" cy="4183380"/>
-          </a:xfrm>
-          <a:prstGeom prst="rect">
-            <a:avLst/>
-          </a:prstGeom>
-        </p:spPr>
-      </p:pic>
-      <p:sp>
-        <p:nvSpPr>
-          <p:cNvPr id="6" name="TextBox 5"/>
-          <p:cNvSpPr txBox="1"/>
-          <p:nvPr/>
-        </p:nvSpPr>
-        <p:spPr>
-          <a:xfrm>
-            <a:off x="6035040" y="6172200"/>
-            <a:ext cx="5577840" cy="365760"/>
-          </a:xfrm>
-          <a:prstGeom prst="rect">
-            <a:avLst/>
-          </a:prstGeom>
-          <a:noFill/>
-        </p:spPr>
-        <p:txBody>
-          <a:bodyPr wrap="none">
-            <a:spAutoFit/>
-          </a:bodyPr>
-          <a:lstStyle/>
-          <a:p>
-            <a:pPr algn="ctr">
-              <a:defRPr sz="1300" i="1">
-                <a:solidFill>
-                  <a:srgbClr val="555555"/>
-                </a:solidFill>
-              </a:defRPr>
-            </a:pPr>
-            <a:r>
-              <a:t>MiraBest confusion matrix — 90.9% accuracy</a:t>
-            </a:r>
-          </a:p>
-        </p:txBody>
-      </p:sp>
-    </p:spTree>
-  </p:cSld>
-  <p:clrMapOvr>
-    <a:masterClrMapping/>
-  </p:clrMapOvr>
-</p:sld>
-</file>
-
-<file path=ppt/slides/slide6.xml><?xml version="1.0" encoding="utf-8"?>
-<p:sld xmlns:a="http://schemas.openxmlformats.org/drawingml/2006/main" xmlns:p="http://schemas.openxmlformats.org/presentationml/2006/main" xmlns:r="http://schemas.openxmlformats.org/officeDocument/2006/relationships">
-  <p:cSld>
-    <p:spTree>
-      <p:nvGrpSpPr>
-        <p:cNvPr id="1" name=""/>
-        <p:cNvGrpSpPr/>
-        <p:nvPr/>
-      </p:nvGrpSpPr>
-      <p:grpSpPr/>
-      <p:sp>
-        <p:nvSpPr>
-          <p:cNvPr id="2" name="TextBox 1"/>
-          <p:cNvSpPr txBox="1"/>
-          <p:nvPr/>
-        </p:nvSpPr>
-        <p:spPr>
-          <a:xfrm>
-            <a:off x="548640" y="320040"/>
-            <a:ext cx="11094415" cy="914400"/>
-          </a:xfrm>
-          <a:prstGeom prst="rect">
-            <a:avLst/>
-          </a:prstGeom>
-          <a:noFill/>
-        </p:spPr>
-        <p:txBody>
-          <a:bodyPr wrap="square">
-            <a:spAutoFit/>
-          </a:bodyPr>
-          <a:lstStyle/>
-          <a:p>
-            <a:pPr>
-              <a:defRPr sz="3600" b="1">
-                <a:solidFill>
-                  <a:srgbClr val="1B2A4A"/>
-                </a:solidFill>
-              </a:defRPr>
-            </a:pPr>
-            <a:r>
-              <a:t>ResNet18: What We're Fine-Tuning</a:t>
-            </a:r>
-          </a:p>
-        </p:txBody>
-      </p:sp>
-      <p:sp>
-        <p:nvSpPr>
-          <p:cNvPr id="3" name="Rectangle 2"/>
+              </a:rPr>
+              <a:t>x0
+(image)</a:t>
+            </a:r>
+          </a:p>
+        </p:txBody>
+      </p:sp>
+      <p:sp>
+        <p:nvSpPr>
+          <p:cNvPr id="7" name="Rounded Rectangle 6"/>
           <p:cNvSpPr/>
           <p:nvPr/>
         </p:nvSpPr>
         <p:spPr>
           <a:xfrm>
-            <a:off x="548640" y="1143000"/>
-            <a:ext cx="2011680" cy="38100"/>
-          </a:xfrm>
-          <a:prstGeom prst="rect">
+            <a:off x="3073000" y="2700000"/>
+            <a:ext cx="1500000" cy="1400000"/>
+          </a:xfrm>
+          <a:prstGeom prst="roundRect">
             <a:avLst/>
           </a:prstGeom>
           <a:solidFill>
-            <a:srgbClr val="2E86C1"/>
+            <a:srgbClr val="498BB7"/>
           </a:solidFill>
-          <a:ln>
-            <a:noFill/>
+          <a:ln w="12700">
+            <a:solidFill>
+              <a:srgbClr val="1B2A4A"/>
+            </a:solidFill>
           </a:ln>
+          <a:effectLst/>
         </p:spPr>
         <p:style>
           <a:lnRef idx="1">
@@ -4957,19 +4836,20 @@
           <a:lstStyle/>
           <a:p>
             <a:pPr algn="ctr"/>
-          </a:p>
-        </p:txBody>
-      </p:sp>
-      <p:sp>
-        <p:nvSpPr>
-          <p:cNvPr id="4" name="TextBox 3"/>
+            <a:endParaRPr/>
+          </a:p>
+        </p:txBody>
+      </p:sp>
+      <p:sp>
+        <p:nvSpPr>
+          <p:cNvPr id="8" name="TextBox 7"/>
           <p:cNvSpPr txBox="1"/>
           <p:nvPr/>
         </p:nvSpPr>
         <p:spPr>
           <a:xfrm>
-            <a:off x="548640" y="1417320"/>
-            <a:ext cx="10972800" cy="2377440"/>
+            <a:off x="3073000" y="4160000"/>
+            <a:ext cx="1500000" cy="400000"/>
           </a:xfrm>
           <a:prstGeom prst="rect">
             <a:avLst/>
@@ -4982,164 +4862,41 @@
           </a:bodyPr>
           <a:lstStyle/>
           <a:p>
-            <a:pPr>
-              <a:spcAft>
-                <a:spcPts val="1000"/>
-              </a:spcAft>
-              <a:defRPr sz="1800">
+            <a:pPr algn="ctr"/>
+            <a:r>
+              <a:rPr sz="1600" b="1">
                 <a:solidFill>
                   <a:srgbClr val="222222"/>
                 </a:solidFill>
-              </a:defRPr>
-            </a:pPr>
-            <a:r>
-              <a:t>•  ResNet18 has ~11.2 million parameters, arranged in a stem + 4 residual "layer" blocks + a final classification head</a:t>
-            </a:r>
-          </a:p>
-          <a:p>
-            <a:pPr>
-              <a:spcAft>
-                <a:spcPts val="1000"/>
-              </a:spcAft>
-              <a:defRPr sz="1800">
-                <a:solidFill>
-                  <a:srgbClr val="222222"/>
-                </a:solidFill>
-              </a:defRPr>
-            </a:pPr>
-            <a:r>
-              <a:t>•  Pretrained on ImageNet (natural photos) — the early layers learn general shape/edge features that transfer reasonably well</a:t>
-            </a:r>
-          </a:p>
-          <a:p>
-            <a:pPr>
-              <a:spcAft>
-                <a:spcPts val="1000"/>
-              </a:spcAft>
-              <a:defRPr sz="1800">
-                <a:solidFill>
-                  <a:srgbClr val="222222"/>
-                </a:solidFill>
-              </a:defRPr>
-            </a:pPr>
-            <a:r>
-              <a:t>•  We freeze layer1–layer3 (the early/mid layers) and only fine-tune layer4 + the head on our radio galaxy images</a:t>
-            </a:r>
-          </a:p>
-          <a:p>
-            <a:pPr>
-              <a:spcAft>
-                <a:spcPts val="1000"/>
-              </a:spcAft>
-              <a:defRPr sz="1800">
-                <a:solidFill>
-                  <a:srgbClr val="222222"/>
-                </a:solidFill>
-              </a:defRPr>
-            </a:pPr>
-            <a:r>
-              <a:t>•  layer4 still holds ~75% of all parameters — so "only fine-tuning one block" is not as small a change as it sounds</a:t>
-            </a:r>
-          </a:p>
-        </p:txBody>
-      </p:sp>
-      <p:pic>
-        <p:nvPicPr>
-          <p:cNvPr id="5" name="Picture 4" descr="resnet18_finetune_diagram.png"/>
-          <p:cNvPicPr>
-            <a:picLocks noChangeAspect="1"/>
-          </p:cNvPicPr>
-          <p:nvPr/>
-        </p:nvPicPr>
-        <p:blipFill>
-          <a:blip r:embed="rId2"/>
-          <a:stretch>
-            <a:fillRect/>
-          </a:stretch>
-        </p:blipFill>
-        <p:spPr>
-          <a:xfrm>
-            <a:off x="1999567" y="3931920"/>
-            <a:ext cx="8162385" cy="2651760"/>
-          </a:xfrm>
-          <a:prstGeom prst="rect">
-            <a:avLst/>
-          </a:prstGeom>
-        </p:spPr>
-      </p:pic>
-    </p:spTree>
-  </p:cSld>
-  <p:clrMapOvr>
-    <a:masterClrMapping/>
-  </p:clrMapOvr>
-</p:sld>
-</file>
-
-<file path=ppt/slides/slide7.xml><?xml version="1.0" encoding="utf-8"?>
-<p:sld xmlns:a="http://schemas.openxmlformats.org/drawingml/2006/main" xmlns:p="http://schemas.openxmlformats.org/presentationml/2006/main" xmlns:r="http://schemas.openxmlformats.org/officeDocument/2006/relationships">
-  <p:cSld>
-    <p:spTree>
-      <p:nvGrpSpPr>
-        <p:cNvPr id="1" name=""/>
-        <p:cNvGrpSpPr/>
-        <p:nvPr/>
-      </p:nvGrpSpPr>
-      <p:grpSpPr/>
-      <p:sp>
-        <p:nvSpPr>
-          <p:cNvPr id="2" name="TextBox 1"/>
-          <p:cNvSpPr txBox="1"/>
-          <p:nvPr/>
-        </p:nvSpPr>
-        <p:spPr>
-          <a:xfrm>
-            <a:off x="548640" y="320040"/>
-            <a:ext cx="11094415" cy="914400"/>
-          </a:xfrm>
-          <a:prstGeom prst="rect">
-            <a:avLst/>
-          </a:prstGeom>
-          <a:noFill/>
-        </p:spPr>
-        <p:txBody>
-          <a:bodyPr wrap="square">
-            <a:spAutoFit/>
-          </a:bodyPr>
-          <a:lstStyle/>
-          <a:p>
-            <a:pPr>
-              <a:defRPr sz="3600" b="1">
-                <a:solidFill>
-                  <a:srgbClr val="1B2A4A"/>
-                </a:solidFill>
-              </a:defRPr>
-            </a:pPr>
-            <a:r>
-              <a:t>Tightening Regularization</a:t>
-            </a:r>
-          </a:p>
-        </p:txBody>
-      </p:sp>
-      <p:sp>
-        <p:nvSpPr>
-          <p:cNvPr id="3" name="Rectangle 2"/>
+              </a:rPr>
+              <a:t>x1</a:t>
+            </a:r>
+          </a:p>
+        </p:txBody>
+      </p:sp>
+      <p:sp>
+        <p:nvSpPr>
+          <p:cNvPr id="9" name="Rounded Rectangle 8"/>
           <p:cNvSpPr/>
           <p:nvPr/>
         </p:nvSpPr>
         <p:spPr>
           <a:xfrm>
-            <a:off x="548640" y="1143000"/>
-            <a:ext cx="2011680" cy="38100"/>
-          </a:xfrm>
-          <a:prstGeom prst="rect">
+            <a:off x="5346000" y="2700000"/>
+            <a:ext cx="1500000" cy="1400000"/>
+          </a:xfrm>
+          <a:prstGeom prst="roundRect">
             <a:avLst/>
           </a:prstGeom>
           <a:solidFill>
-            <a:srgbClr val="2E86C1"/>
+            <a:srgbClr val="6490AD"/>
           </a:solidFill>
-          <a:ln>
-            <a:noFill/>
+          <a:ln w="12700">
+            <a:solidFill>
+              <a:srgbClr val="1B2A4A"/>
+            </a:solidFill>
           </a:ln>
+          <a:effectLst/>
         </p:spPr>
         <p:style>
           <a:lnRef idx="1">
@@ -5160,19 +4917,20 @@
           <a:lstStyle/>
           <a:p>
             <a:pPr algn="ctr"/>
-          </a:p>
-        </p:txBody>
-      </p:sp>
-      <p:sp>
-        <p:nvSpPr>
-          <p:cNvPr id="4" name="TextBox 3"/>
+            <a:endParaRPr/>
+          </a:p>
+        </p:txBody>
+      </p:sp>
+      <p:sp>
+        <p:nvSpPr>
+          <p:cNvPr id="10" name="TextBox 9"/>
           <p:cNvSpPr txBox="1"/>
           <p:nvPr/>
         </p:nvSpPr>
         <p:spPr>
           <a:xfrm>
-            <a:off x="548640" y="1417320"/>
-            <a:ext cx="10972800" cy="4846320"/>
+            <a:off x="5346000" y="4160000"/>
+            <a:ext cx="1500000" cy="400000"/>
           </a:xfrm>
           <a:prstGeom prst="rect">
             <a:avLst/>
@@ -5185,140 +4943,41 @@
           </a:bodyPr>
           <a:lstStyle/>
           <a:p>
-            <a:pPr>
-              <a:spcAft>
-                <a:spcPts val="1000"/>
-              </a:spcAft>
-              <a:defRPr sz="2200">
+            <a:pPr algn="ctr"/>
+            <a:r>
+              <a:rPr sz="1600" b="1">
                 <a:solidFill>
                   <a:srgbClr val="222222"/>
                 </a:solidFill>
-              </a:defRPr>
-            </a:pPr>
-            <a:r>
-              <a:t>•  Added dropout before the final linear layer, on top of the layer-freezing from the previous slide</a:t>
-            </a:r>
-          </a:p>
-          <a:p>
-            <a:pPr>
-              <a:spcAft>
-                <a:spcPts val="1000"/>
-              </a:spcAft>
-              <a:defRPr sz="2200">
-                <a:solidFill>
-                  <a:srgbClr val="222222"/>
-                </a:solidFill>
-              </a:defRPr>
-            </a:pPr>
-            <a:r>
-              <a:t>•  Fixed a real checkpoint bug: the saved model was the last epoch, not the best-val-loss epoch</a:t>
-            </a:r>
-          </a:p>
-          <a:p>
-            <a:pPr lvl="1">
-              <a:spcAft>
-                <a:spcPts val="1000"/>
-              </a:spcAft>
-              <a:defRPr sz="2000">
-                <a:solidFill>
-                  <a:srgbClr val="222222"/>
-                </a:solidFill>
-              </a:defRPr>
-            </a:pPr>
-            <a:r>
-              <a:t>–  Best-epoch weights were only restored in memory, never written back to disk</a:t>
-            </a:r>
-          </a:p>
-          <a:p>
-            <a:pPr lvl="1">
-              <a:spcAft>
-                <a:spcPts val="1000"/>
-              </a:spcAft>
-              <a:defRPr sz="2000">
-                <a:solidFill>
-                  <a:srgbClr val="222222"/>
-                </a:solidFill>
-              </a:defRPr>
-            </a:pPr>
-            <a:r>
-              <a:t>–  Now the saved checkpoint matches the reported test accuracy</a:t>
-            </a:r>
-          </a:p>
-        </p:txBody>
-      </p:sp>
-    </p:spTree>
-  </p:cSld>
-  <p:clrMapOvr>
-    <a:masterClrMapping/>
-  </p:clrMapOvr>
-</p:sld>
-</file>
-
-<file path=ppt/slides/slide8.xml><?xml version="1.0" encoding="utf-8"?>
-<p:sld xmlns:a="http://schemas.openxmlformats.org/drawingml/2006/main" xmlns:p="http://schemas.openxmlformats.org/presentationml/2006/main" xmlns:r="http://schemas.openxmlformats.org/officeDocument/2006/relationships">
-  <p:cSld>
-    <p:spTree>
-      <p:nvGrpSpPr>
-        <p:cNvPr id="1" name=""/>
-        <p:cNvGrpSpPr/>
-        <p:nvPr/>
-      </p:nvGrpSpPr>
-      <p:grpSpPr/>
-      <p:sp>
-        <p:nvSpPr>
-          <p:cNvPr id="2" name="TextBox 1"/>
-          <p:cNvSpPr txBox="1"/>
-          <p:nvPr/>
-        </p:nvSpPr>
-        <p:spPr>
-          <a:xfrm>
-            <a:off x="548640" y="320040"/>
-            <a:ext cx="11094415" cy="914400"/>
-          </a:xfrm>
-          <a:prstGeom prst="rect">
-            <a:avLst/>
-          </a:prstGeom>
-          <a:noFill/>
-        </p:spPr>
-        <p:txBody>
-          <a:bodyPr wrap="square">
-            <a:spAutoFit/>
-          </a:bodyPr>
-          <a:lstStyle/>
-          <a:p>
-            <a:pPr>
-              <a:defRPr sz="3600" b="1">
-                <a:solidFill>
-                  <a:srgbClr val="1B2A4A"/>
-                </a:solidFill>
-              </a:defRPr>
-            </a:pPr>
-            <a:r>
-              <a:t>Class-Conditional Diffusion Generation</a:t>
-            </a:r>
-          </a:p>
-        </p:txBody>
-      </p:sp>
-      <p:sp>
-        <p:nvSpPr>
-          <p:cNvPr id="3" name="Rectangle 2"/>
+              </a:rPr>
+              <a:t>x2</a:t>
+            </a:r>
+          </a:p>
+        </p:txBody>
+      </p:sp>
+      <p:sp>
+        <p:nvSpPr>
+          <p:cNvPr id="11" name="Rounded Rectangle 10"/>
           <p:cNvSpPr/>
           <p:nvPr/>
         </p:nvSpPr>
         <p:spPr>
           <a:xfrm>
-            <a:off x="548640" y="1143000"/>
-            <a:ext cx="2011680" cy="38100"/>
-          </a:xfrm>
-          <a:prstGeom prst="rect">
+            <a:off x="7619000" y="2700000"/>
+            <a:ext cx="1500000" cy="1400000"/>
+          </a:xfrm>
+          <a:prstGeom prst="roundRect">
             <a:avLst/>
           </a:prstGeom>
           <a:solidFill>
-            <a:srgbClr val="2E86C1"/>
+            <a:srgbClr val="7F95A3"/>
           </a:solidFill>
-          <a:ln>
-            <a:noFill/>
+          <a:ln w="12700">
+            <a:solidFill>
+              <a:srgbClr val="1B2A4A"/>
+            </a:solidFill>
           </a:ln>
+          <a:effectLst/>
         </p:spPr>
         <p:style>
           <a:lnRef idx="1">
@@ -5339,19 +4998,20 @@
           <a:lstStyle/>
           <a:p>
             <a:pPr algn="ctr"/>
-          </a:p>
-        </p:txBody>
-      </p:sp>
-      <p:sp>
-        <p:nvSpPr>
-          <p:cNvPr id="4" name="TextBox 3"/>
+            <a:endParaRPr/>
+          </a:p>
+        </p:txBody>
+      </p:sp>
+      <p:sp>
+        <p:nvSpPr>
+          <p:cNvPr id="12" name="TextBox 11"/>
           <p:cNvSpPr txBox="1"/>
           <p:nvPr/>
         </p:nvSpPr>
         <p:spPr>
           <a:xfrm>
-            <a:off x="548640" y="1417320"/>
-            <a:ext cx="10972800" cy="1645920"/>
+            <a:off x="7619000" y="4160000"/>
+            <a:ext cx="1500000" cy="400000"/>
           </a:xfrm>
           <a:prstGeom prst="rect">
             <a:avLst/>
@@ -5364,184 +5024,41 @@
           </a:bodyPr>
           <a:lstStyle/>
           <a:p>
-            <a:pPr>
-              <a:spcAft>
-                <a:spcPts val="1000"/>
-              </a:spcAft>
-              <a:defRPr sz="2000">
+            <a:pPr algn="ctr"/>
+            <a:r>
+              <a:rPr sz="1600" b="1">
                 <a:solidFill>
                   <a:srgbClr val="222222"/>
                 </a:solidFill>
-              </a:defRPr>
-            </a:pPr>
-            <a:r>
-              <a:t>•  UNet2DConditionModel + DDPM, 1000-step training schedule</a:t>
-            </a:r>
-          </a:p>
-          <a:p>
-            <a:pPr>
-              <a:spcAft>
-                <a:spcPts val="1000"/>
-              </a:spcAft>
-              <a:defRPr sz="2000">
-                <a:solidFill>
-                  <a:srgbClr val="222222"/>
-                </a:solidFill>
-              </a:defRPr>
-            </a:pPr>
-            <a:r>
-              <a:t>•  Class embedding + classifier-free guidance (15% label dropout during training)</a:t>
-            </a:r>
-          </a:p>
-          <a:p>
-            <a:pPr>
-              <a:spcAft>
-                <a:spcPts val="1000"/>
-              </a:spcAft>
-              <a:defRPr sz="2000">
-                <a:solidFill>
-                  <a:srgbClr val="222222"/>
-                </a:solidFill>
-              </a:defRPr>
-            </a:pPr>
-            <a:r>
-              <a:t>•  Generates distinct FR-I / FR-II morphology after ~250 epochs</a:t>
-            </a:r>
-          </a:p>
-        </p:txBody>
-      </p:sp>
-      <p:pic>
-        <p:nvPicPr>
-          <p:cNvPr id="5" name="Picture 4" descr="comparison_epoch_250.png"/>
-          <p:cNvPicPr>
-            <a:picLocks noChangeAspect="1"/>
-          </p:cNvPicPr>
-          <p:nvPr/>
-        </p:nvPicPr>
-        <p:blipFill>
-          <a:blip r:embed="rId2"/>
-          <a:stretch>
-            <a:fillRect/>
-          </a:stretch>
-        </p:blipFill>
-        <p:spPr>
-          <a:xfrm>
-            <a:off x="2514600" y="2834640"/>
-            <a:ext cx="7132320" cy="3566160"/>
-          </a:xfrm>
-          <a:prstGeom prst="rect">
-            <a:avLst/>
-          </a:prstGeom>
-        </p:spPr>
-      </p:pic>
-      <p:sp>
-        <p:nvSpPr>
-          <p:cNvPr id="6" name="TextBox 5"/>
-          <p:cNvSpPr txBox="1"/>
-          <p:nvPr/>
-        </p:nvSpPr>
-        <p:spPr>
-          <a:xfrm>
-            <a:off x="2286000" y="6400800"/>
-            <a:ext cx="7589520" cy="365760"/>
-          </a:xfrm>
-          <a:prstGeom prst="rect">
-            <a:avLst/>
-          </a:prstGeom>
-          <a:noFill/>
-        </p:spPr>
-        <p:txBody>
-          <a:bodyPr wrap="none">
-            <a:spAutoFit/>
-          </a:bodyPr>
-          <a:lstStyle/>
-          <a:p>
-            <a:pPr algn="ctr">
-              <a:defRPr sz="1300" i="1">
-                <a:solidFill>
-                  <a:srgbClr val="555555"/>
-                </a:solidFill>
-              </a:defRPr>
-            </a:pPr>
-            <a:r>
-              <a:t>Generated samples, epoch 250 — Class 0 (FR-I) vs Class 1 (FR-II)</a:t>
-            </a:r>
-          </a:p>
-        </p:txBody>
-      </p:sp>
-    </p:spTree>
-  </p:cSld>
-  <p:clrMapOvr>
-    <a:masterClrMapping/>
-  </p:clrMapOvr>
-</p:sld>
-</file>
-
-<file path=ppt/slides/slide9.xml><?xml version="1.0" encoding="utf-8"?>
-<p:sld xmlns:a="http://schemas.openxmlformats.org/drawingml/2006/main" xmlns:p="http://schemas.openxmlformats.org/presentationml/2006/main" xmlns:r="http://schemas.openxmlformats.org/officeDocument/2006/relationships">
-  <p:cSld>
-    <p:spTree>
-      <p:nvGrpSpPr>
-        <p:cNvPr id="1" name=""/>
-        <p:cNvGrpSpPr/>
-        <p:nvPr/>
-      </p:nvGrpSpPr>
-      <p:grpSpPr/>
-      <p:sp>
-        <p:nvSpPr>
-          <p:cNvPr id="2" name="TextBox 1"/>
-          <p:cNvSpPr txBox="1"/>
-          <p:nvPr/>
-        </p:nvSpPr>
-        <p:spPr>
-          <a:xfrm>
-            <a:off x="548640" y="320040"/>
-            <a:ext cx="11094415" cy="914400"/>
-          </a:xfrm>
-          <a:prstGeom prst="rect">
-            <a:avLst/>
-          </a:prstGeom>
-          <a:noFill/>
-        </p:spPr>
-        <p:txBody>
-          <a:bodyPr wrap="square">
-            <a:spAutoFit/>
-          </a:bodyPr>
-          <a:lstStyle/>
-          <a:p>
-            <a:pPr>
-              <a:defRPr sz="3600" b="1">
-                <a:solidFill>
-                  <a:srgbClr val="1B2A4A"/>
-                </a:solidFill>
-              </a:defRPr>
-            </a:pPr>
-            <a:r>
-              <a:t>Physics-Informed Diffusion (PID)</a:t>
-            </a:r>
-          </a:p>
-        </p:txBody>
-      </p:sp>
-      <p:sp>
-        <p:nvSpPr>
-          <p:cNvPr id="3" name="Rectangle 2"/>
+              </a:rPr>
+              <a:t>x3</a:t>
+            </a:r>
+          </a:p>
+        </p:txBody>
+      </p:sp>
+      <p:sp>
+        <p:nvSpPr>
+          <p:cNvPr id="13" name="Rounded Rectangle 12"/>
           <p:cNvSpPr/>
           <p:nvPr/>
         </p:nvSpPr>
         <p:spPr>
           <a:xfrm>
-            <a:off x="548640" y="1143000"/>
-            <a:ext cx="2011680" cy="38100"/>
-          </a:xfrm>
-          <a:prstGeom prst="rect">
+            <a:off x="9892000" y="2700000"/>
+            <a:ext cx="1500000" cy="1400000"/>
+          </a:xfrm>
+          <a:prstGeom prst="roundRect">
             <a:avLst/>
           </a:prstGeom>
           <a:solidFill>
-            <a:srgbClr val="2E86C1"/>
+            <a:srgbClr val="9A9A9A"/>
           </a:solidFill>
-          <a:ln>
-            <a:noFill/>
+          <a:ln w="12700">
+            <a:solidFill>
+              <a:srgbClr val="1B2A4A"/>
+            </a:solidFill>
           </a:ln>
+          <a:effectLst/>
         </p:spPr>
         <p:style>
           <a:lnRef idx="1">
@@ -5562,6 +5079,345 @@
           <a:lstStyle/>
           <a:p>
             <a:pPr algn="ctr"/>
+            <a:endParaRPr/>
+          </a:p>
+        </p:txBody>
+      </p:sp>
+      <p:sp>
+        <p:nvSpPr>
+          <p:cNvPr id="14" name="TextBox 13"/>
+          <p:cNvSpPr txBox="1"/>
+          <p:nvPr/>
+        </p:nvSpPr>
+        <p:spPr>
+          <a:xfrm>
+            <a:off x="9892000" y="4160000"/>
+            <a:ext cx="1500000" cy="400000"/>
+          </a:xfrm>
+          <a:prstGeom prst="rect">
+            <a:avLst/>
+          </a:prstGeom>
+          <a:noFill/>
+        </p:spPr>
+        <p:txBody>
+          <a:bodyPr wrap="square">
+            <a:spAutoFit/>
+          </a:bodyPr>
+          <a:lstStyle/>
+          <a:p>
+            <a:pPr algn="ctr"/>
+            <a:r>
+              <a:rPr sz="1600" b="1">
+                <a:solidFill>
+                  <a:srgbClr val="222222"/>
+                </a:solidFill>
+              </a:rPr>
+              <a:t>xT
+(noise)</a:t>
+            </a:r>
+          </a:p>
+        </p:txBody>
+      </p:sp>
+      <p:sp>
+        <p:nvSpPr>
+          <p:cNvPr id="15" name="Right Arrow 14"/>
+          <p:cNvSpPr/>
+          <p:nvPr/>
+        </p:nvSpPr>
+        <p:spPr>
+          <a:xfrm>
+            <a:off x="2300000" y="2250000"/>
+            <a:ext cx="7592000" cy="260000"/>
+          </a:xfrm>
+          <a:prstGeom prst="rightArrow">
+            <a:avLst/>
+          </a:prstGeom>
+          <a:solidFill>
+            <a:srgbClr val="2E86C1"/>
+          </a:solidFill>
+          <a:ln>
+            <a:noFill/>
+          </a:ln>
+          <a:effectLst/>
+        </p:spPr>
+        <p:style>
+          <a:lnRef idx="1">
+            <a:schemeClr val="accent1"/>
+          </a:lnRef>
+          <a:fillRef idx="3">
+            <a:schemeClr val="accent1"/>
+          </a:fillRef>
+          <a:effectRef idx="2">
+            <a:schemeClr val="accent1"/>
+          </a:effectRef>
+          <a:fontRef idx="minor">
+            <a:schemeClr val="lt1"/>
+          </a:fontRef>
+        </p:style>
+        <p:txBody>
+          <a:bodyPr rtlCol="0" anchor="ctr"/>
+          <a:lstStyle/>
+          <a:p>
+            <a:pPr algn="ctr"/>
+            <a:endParaRPr/>
+          </a:p>
+        </p:txBody>
+      </p:sp>
+      <p:sp>
+        <p:nvSpPr>
+          <p:cNvPr id="16" name="TextBox 15"/>
+          <p:cNvSpPr txBox="1"/>
+          <p:nvPr/>
+        </p:nvSpPr>
+        <p:spPr>
+          <a:xfrm>
+            <a:off x="2300000" y="1870000"/>
+            <a:ext cx="7592000" cy="360000"/>
+          </a:xfrm>
+          <a:prstGeom prst="rect">
+            <a:avLst/>
+          </a:prstGeom>
+          <a:noFill/>
+        </p:spPr>
+        <p:txBody>
+          <a:bodyPr wrap="square">
+            <a:spAutoFit/>
+          </a:bodyPr>
+          <a:lstStyle/>
+          <a:p>
+            <a:pPr algn="ctr"/>
+            <a:r>
+              <a:rPr sz="1500" i="1">
+                <a:solidFill>
+                  <a:srgbClr val="555555"/>
+                </a:solidFill>
+              </a:rPr>
+              <a:t>Forward process: add noise  q(xt | xt-1)</a:t>
+            </a:r>
+          </a:p>
+        </p:txBody>
+      </p:sp>
+      <p:sp>
+        <p:nvSpPr>
+          <p:cNvPr id="17" name="Left Arrow 16"/>
+          <p:cNvSpPr/>
+          <p:nvPr/>
+        </p:nvSpPr>
+        <p:spPr>
+          <a:xfrm>
+            <a:off x="2300000" y="4560000"/>
+            <a:ext cx="7592000" cy="260000"/>
+          </a:xfrm>
+          <a:prstGeom prst="leftArrow">
+            <a:avLst/>
+          </a:prstGeom>
+          <a:solidFill>
+            <a:srgbClr val="1B2A4A"/>
+          </a:solidFill>
+          <a:ln>
+            <a:noFill/>
+          </a:ln>
+          <a:effectLst/>
+        </p:spPr>
+        <p:style>
+          <a:lnRef idx="1">
+            <a:schemeClr val="accent1"/>
+          </a:lnRef>
+          <a:fillRef idx="3">
+            <a:schemeClr val="accent1"/>
+          </a:fillRef>
+          <a:effectRef idx="2">
+            <a:schemeClr val="accent1"/>
+          </a:effectRef>
+          <a:fontRef idx="minor">
+            <a:schemeClr val="lt1"/>
+          </a:fontRef>
+        </p:style>
+        <p:txBody>
+          <a:bodyPr rtlCol="0" anchor="ctr"/>
+          <a:lstStyle/>
+          <a:p>
+            <a:pPr algn="ctr"/>
+            <a:endParaRPr/>
+          </a:p>
+        </p:txBody>
+      </p:sp>
+      <p:sp>
+        <p:nvSpPr>
+          <p:cNvPr id="18" name="TextBox 17"/>
+          <p:cNvSpPr txBox="1"/>
+          <p:nvPr/>
+        </p:nvSpPr>
+        <p:spPr>
+          <a:xfrm>
+            <a:off x="2300000" y="4860000"/>
+            <a:ext cx="7592000" cy="360000"/>
+          </a:xfrm>
+          <a:prstGeom prst="rect">
+            <a:avLst/>
+          </a:prstGeom>
+          <a:noFill/>
+        </p:spPr>
+        <p:txBody>
+          <a:bodyPr wrap="square">
+            <a:spAutoFit/>
+          </a:bodyPr>
+          <a:lstStyle/>
+          <a:p>
+            <a:pPr algn="ctr"/>
+            <a:r>
+              <a:rPr sz="1500" i="1">
+                <a:solidFill>
+                  <a:srgbClr val="555555"/>
+                </a:solidFill>
+              </a:rPr>
+              <a:t>Reverse process: predict &amp; remove noise  p(theta)(xt-1 | xt) - learned by U-Net</a:t>
+            </a:r>
+          </a:p>
+        </p:txBody>
+      </p:sp>
+      <p:sp>
+        <p:nvSpPr>
+          <p:cNvPr id="19" name="TextBox 18"/>
+          <p:cNvSpPr txBox="1"/>
+          <p:nvPr/>
+        </p:nvSpPr>
+        <p:spPr>
+          <a:xfrm>
+            <a:off x="548640" y="6420000"/>
+            <a:ext cx="11094720" cy="365760"/>
+          </a:xfrm>
+          <a:prstGeom prst="rect">
+            <a:avLst/>
+          </a:prstGeom>
+          <a:noFill/>
+        </p:spPr>
+        <p:txBody>
+          <a:bodyPr wrap="none">
+            <a:spAutoFit/>
+          </a:bodyPr>
+          <a:lstStyle/>
+          <a:p>
+            <a:pPr algn="ctr"/>
+            <a:r>
+              <a:rPr sz="1300" i="1">
+                <a:solidFill>
+                  <a:srgbClr val="555555"/>
+                </a:solidFill>
+              </a:rPr>
+              <a:t>Training: the U-Net learns to predict the noise added at each step; generation runs the reverse process from pure noise.</a:t>
+            </a:r>
+          </a:p>
+        </p:txBody>
+      </p:sp>
+    </p:spTree>
+    <p:extLst>
+      <p:ext uri="{BB962C8B-B14F-4D97-AF65-F5344CB8AC3E}">
+        <p14:creationId xmlns:p14="http://schemas.microsoft.com/office/powerpoint/2010/main" val="1215173029"/>
+      </p:ext>
+    </p:extLst>
+  </p:cSld>
+  <p:clrMapOvr>
+    <a:masterClrMapping/>
+  </p:clrMapOvr>
+</p:sld>
+</file>
+
+<file path=ppt/slides/slide5.xml><?xml version="1.0" encoding="utf-8"?>
+<p:sld xmlns:a="http://schemas.openxmlformats.org/drawingml/2006/main" xmlns:r="http://schemas.openxmlformats.org/officeDocument/2006/relationships" xmlns:p="http://schemas.openxmlformats.org/presentationml/2006/main">
+  <p:cSld>
+    <p:spTree>
+      <p:nvGrpSpPr>
+        <p:cNvPr id="1" name=""/>
+        <p:cNvGrpSpPr/>
+        <p:nvPr/>
+      </p:nvGrpSpPr>
+      <p:grpSpPr>
+        <a:xfrm>
+          <a:off x="0" y="0"/>
+          <a:ext cx="0" cy="0"/>
+          <a:chOff x="0" y="0"/>
+          <a:chExt cx="0" cy="0"/>
+        </a:xfrm>
+      </p:grpSpPr>
+      <p:sp>
+        <p:nvSpPr>
+          <p:cNvPr id="2" name="TextBox 1"/>
+          <p:cNvSpPr txBox="1"/>
+          <p:nvPr/>
+        </p:nvSpPr>
+        <p:spPr>
+          <a:xfrm>
+            <a:off x="548640" y="320040"/>
+            <a:ext cx="11094415" cy="646331"/>
+          </a:xfrm>
+          <a:prstGeom prst="rect">
+            <a:avLst/>
+          </a:prstGeom>
+          <a:noFill/>
+        </p:spPr>
+        <p:txBody>
+          <a:bodyPr wrap="square">
+            <a:spAutoFit/>
+          </a:bodyPr>
+          <a:lstStyle/>
+          <a:p>
+            <a:pPr>
+              <a:defRPr sz="3600" b="1">
+                <a:solidFill>
+                  <a:srgbClr val="1B2A4A"/>
+                </a:solidFill>
+              </a:defRPr>
+            </a:pPr>
+            <a:r>
+              <a:rPr dirty="0"/>
+              <a:t>Data Pipeline:</a:t>
+            </a:r>
+          </a:p>
+        </p:txBody>
+      </p:sp>
+      <p:sp>
+        <p:nvSpPr>
+          <p:cNvPr id="3" name="Rectangle 2"/>
+          <p:cNvSpPr/>
+          <p:nvPr/>
+        </p:nvSpPr>
+        <p:spPr>
+          <a:xfrm>
+            <a:off x="548640" y="1143000"/>
+            <a:ext cx="2011680" cy="38100"/>
+          </a:xfrm>
+          <a:prstGeom prst="rect">
+            <a:avLst/>
+          </a:prstGeom>
+          <a:solidFill>
+            <a:srgbClr val="2E86C1"/>
+          </a:solidFill>
+          <a:ln>
+            <a:noFill/>
+          </a:ln>
+          <a:effectLst/>
+        </p:spPr>
+        <p:style>
+          <a:lnRef idx="1">
+            <a:schemeClr val="accent1"/>
+          </a:lnRef>
+          <a:fillRef idx="3">
+            <a:schemeClr val="accent1"/>
+          </a:fillRef>
+          <a:effectRef idx="2">
+            <a:schemeClr val="accent1"/>
+          </a:effectRef>
+          <a:fontRef idx="minor">
+            <a:schemeClr val="lt1"/>
+          </a:fontRef>
+        </p:style>
+        <p:txBody>
+          <a:bodyPr rtlCol="0" anchor="ctr"/>
+          <a:lstStyle/>
+          <a:p>
+            <a:pPr algn="ctr"/>
+            <a:endParaRPr/>
           </a:p>
         </p:txBody>
       </p:sp>
@@ -5574,7 +5430,7 @@
         <p:spPr>
           <a:xfrm>
             <a:off x="548640" y="1417320"/>
-            <a:ext cx="10972800" cy="2103120"/>
+            <a:ext cx="11094415" cy="1733808"/>
           </a:xfrm>
           <a:prstGeom prst="rect">
             <a:avLst/>
@@ -5591,44 +5447,51 @@
               <a:spcAft>
                 <a:spcPts val="1000"/>
               </a:spcAft>
-              <a:defRPr sz="1900">
+              <a:defRPr sz="1800">
                 <a:solidFill>
                   <a:srgbClr val="222222"/>
                 </a:solidFill>
               </a:defRPr>
             </a:pPr>
             <a:r>
-              <a:t>•  Adds two physics-motivated loss terms to generation:</a:t>
-            </a:r>
-          </a:p>
-          <a:p>
-            <a:pPr lvl="1">
-              <a:spcAft>
-                <a:spcPts val="1000"/>
-              </a:spcAft>
-              <a:defRPr sz="1700">
-                <a:solidFill>
-                  <a:srgbClr val="222222"/>
-                </a:solidFill>
-              </a:defRPr>
-            </a:pPr>
-            <a:r>
-              <a:t>–  Bilateral symmetry — radio jets are approximately symmetric about the core</a:t>
-            </a:r>
-          </a:p>
-          <a:p>
-            <a:pPr lvl="1">
-              <a:spcAft>
-                <a:spcPts val="1000"/>
-              </a:spcAft>
-              <a:defRPr sz="1700">
-                <a:solidFill>
-                  <a:srgbClr val="222222"/>
-                </a:solidFill>
-              </a:defRPr>
-            </a:pPr>
-            <a:r>
-              <a:t>–  Non-negative flux — real flux measurements cannot be negative</a:t>
+              <a:rPr dirty="0"/>
+              <a:t>•  Training prep —</a:t>
+            </a:r>
+            <a:r>
+              <a:rPr lang="en-US" dirty="0"/>
+              <a:t> </a:t>
+            </a:r>
+            <a:r>
+              <a:rPr dirty="0"/>
+              <a:t>convert</a:t>
+            </a:r>
+            <a:r>
+              <a:rPr lang="en-US" dirty="0"/>
+              <a:t> </a:t>
+            </a:r>
+            <a:r>
+              <a:rPr dirty="0"/>
+              <a:t>each </a:t>
+            </a:r>
+            <a:r>
+              <a:rPr dirty="0" err="1"/>
+              <a:t>MiraBest</a:t>
+            </a:r>
+            <a:r>
+              <a:rPr dirty="0"/>
+              <a:t> FITS </a:t>
+            </a:r>
+            <a:r>
+              <a:rPr lang="en-ZA" dirty="0"/>
+              <a:t>image with the same </a:t>
+            </a:r>
+            <a:r>
+              <a:rPr lang="en-ZA" dirty="0" err="1"/>
+              <a:t>sym</a:t>
+            </a:r>
+            <a:r>
+              <a:rPr lang="en-ZA" dirty="0"/>
+              <a:t>-log-SNR normalisation used at train time (clipped to [-1, 1])</a:t>
             </a:r>
           </a:p>
           <a:p>
@@ -5636,21 +5499,460 @@
               <a:spcAft>
                 <a:spcPts val="1000"/>
               </a:spcAft>
-              <a:defRPr sz="1900">
+              <a:defRPr sz="1800">
                 <a:solidFill>
                   <a:srgbClr val="222222"/>
                 </a:solidFill>
               </a:defRPr>
             </a:pPr>
             <a:r>
-              <a:t>•  Tuning finding: non-negativity loss was over-weighted and made images artificially bright — lambda_neg reduced to 0</a:t>
+              <a:rPr dirty="0"/>
+              <a:t>•</a:t>
+            </a:r>
+            <a:r>
+              <a:rPr lang="en-US" dirty="0"/>
+              <a:t> Diffusion model trained on the transformed/normalized data</a:t>
+            </a:r>
+          </a:p>
+          <a:p>
+            <a:pPr>
+              <a:spcAft>
+                <a:spcPts val="1000"/>
+              </a:spcAft>
+              <a:defRPr sz="1800">
+                <a:solidFill>
+                  <a:srgbClr val="222222"/>
+                </a:solidFill>
+              </a:defRPr>
+            </a:pPr>
+            <a:r>
+              <a:rPr dirty="0"/>
+              <a:t>•  After generation — diffusion output tensors are inverted with </a:t>
+            </a:r>
+            <a:r>
+              <a:rPr lang="en-US" dirty="0"/>
+              <a:t>a denormalization function </a:t>
+            </a:r>
+            <a:r>
+              <a:rPr dirty="0"/>
+              <a:t>(</a:t>
+            </a:r>
+            <a:r>
+              <a:rPr dirty="0" err="1"/>
+              <a:t>sym</a:t>
+            </a:r>
+            <a:r>
+              <a:rPr dirty="0"/>
+              <a:t>-log-SNR → approximate Jy/beam) and written back out as real FITS files</a:t>
+            </a:r>
+            <a:endParaRPr lang="en-ZA" dirty="0"/>
+          </a:p>
+        </p:txBody>
+      </p:sp>
+    </p:spTree>
+  </p:cSld>
+  <p:clrMapOvr>
+    <a:masterClrMapping/>
+  </p:clrMapOvr>
+</p:sld>
+</file>
+
+<file path=ppt/slides/slide6.xml><?xml version="1.0" encoding="utf-8"?>
+<p:sld xmlns:a="http://schemas.openxmlformats.org/drawingml/2006/main" xmlns:r="http://schemas.openxmlformats.org/officeDocument/2006/relationships" xmlns:p="http://schemas.openxmlformats.org/presentationml/2006/main">
+  <p:cSld>
+    <p:spTree>
+      <p:nvGrpSpPr>
+        <p:cNvPr id="1" name=""/>
+        <p:cNvGrpSpPr/>
+        <p:nvPr/>
+      </p:nvGrpSpPr>
+      <p:grpSpPr>
+        <a:xfrm>
+          <a:off x="0" y="0"/>
+          <a:ext cx="0" cy="0"/>
+          <a:chOff x="0" y="0"/>
+          <a:chExt cx="0" cy="0"/>
+        </a:xfrm>
+      </p:grpSpPr>
+      <p:sp>
+        <p:nvSpPr>
+          <p:cNvPr id="2" name="TextBox 1"/>
+          <p:cNvSpPr txBox="1"/>
+          <p:nvPr/>
+        </p:nvSpPr>
+        <p:spPr>
+          <a:xfrm>
+            <a:off x="548640" y="320040"/>
+            <a:ext cx="11094415" cy="914400"/>
+          </a:xfrm>
+          <a:prstGeom prst="rect">
+            <a:avLst/>
+          </a:prstGeom>
+          <a:noFill/>
+        </p:spPr>
+        <p:txBody>
+          <a:bodyPr wrap="square">
+            <a:spAutoFit/>
+          </a:bodyPr>
+          <a:lstStyle/>
+          <a:p>
+            <a:pPr>
+              <a:defRPr sz="3600" b="1">
+                <a:solidFill>
+                  <a:srgbClr val="1B2A4A"/>
+                </a:solidFill>
+              </a:defRPr>
+            </a:pPr>
+            <a:r>
+              <a:t>Project Architecture</a:t>
+            </a:r>
+          </a:p>
+        </p:txBody>
+      </p:sp>
+      <p:sp>
+        <p:nvSpPr>
+          <p:cNvPr id="3" name="Rectangle 2"/>
+          <p:cNvSpPr/>
+          <p:nvPr/>
+        </p:nvSpPr>
+        <p:spPr>
+          <a:xfrm>
+            <a:off x="548640" y="1143000"/>
+            <a:ext cx="2011680" cy="38100"/>
+          </a:xfrm>
+          <a:prstGeom prst="rect">
+            <a:avLst/>
+          </a:prstGeom>
+          <a:solidFill>
+            <a:srgbClr val="2E86C1"/>
+          </a:solidFill>
+          <a:ln>
+            <a:noFill/>
+          </a:ln>
+        </p:spPr>
+        <p:style>
+          <a:lnRef idx="1">
+            <a:schemeClr val="accent1"/>
+          </a:lnRef>
+          <a:fillRef idx="3">
+            <a:schemeClr val="accent1"/>
+          </a:fillRef>
+          <a:effectRef idx="2">
+            <a:schemeClr val="accent1"/>
+          </a:effectRef>
+          <a:fontRef idx="minor">
+            <a:schemeClr val="lt1"/>
+          </a:fontRef>
+        </p:style>
+        <p:txBody>
+          <a:bodyPr rtlCol="0" anchor="ctr"/>
+          <a:lstStyle/>
+          <a:p>
+            <a:pPr algn="ctr"/>
+            <a:endParaRPr/>
+          </a:p>
+        </p:txBody>
+      </p:sp>
+      <p:sp>
+        <p:nvSpPr>
+          <p:cNvPr id="4" name="TextBox 3"/>
+          <p:cNvSpPr txBox="1"/>
+          <p:nvPr/>
+        </p:nvSpPr>
+        <p:spPr>
+          <a:xfrm>
+            <a:off x="548640" y="1417320"/>
+            <a:ext cx="10972800" cy="3313728"/>
+          </a:xfrm>
+          <a:prstGeom prst="rect">
+            <a:avLst/>
+          </a:prstGeom>
+          <a:noFill/>
+        </p:spPr>
+        <p:txBody>
+          <a:bodyPr wrap="square">
+            <a:spAutoFit/>
+          </a:bodyPr>
+          <a:lstStyle/>
+          <a:p>
+            <a:pPr>
+              <a:spcAft>
+                <a:spcPts val="1000"/>
+              </a:spcAft>
+              <a:defRPr sz="2200">
+                <a:solidFill>
+                  <a:srgbClr val="222222"/>
+                </a:solidFill>
+              </a:defRPr>
+            </a:pPr>
+            <a:r>
+              <a:rPr dirty="0"/>
+              <a:t>•  1. Classifier — ResNet18, distinguishes FR-I / FR-II</a:t>
+            </a:r>
+          </a:p>
+          <a:p>
+            <a:pPr>
+              <a:spcAft>
+                <a:spcPts val="1000"/>
+              </a:spcAft>
+              <a:defRPr sz="2200">
+                <a:solidFill>
+                  <a:srgbClr val="222222"/>
+                </a:solidFill>
+              </a:defRPr>
+            </a:pPr>
+            <a:r>
+              <a:rPr dirty="0"/>
+              <a:t>•  2. </a:t>
+            </a:r>
+            <a:r>
+              <a:rPr lang="en-US" dirty="0"/>
+              <a:t>D</a:t>
+            </a:r>
+            <a:r>
+              <a:rPr dirty="0"/>
+              <a:t>iffusion —</a:t>
+            </a:r>
+            <a:r>
+              <a:rPr lang="en-US" dirty="0"/>
+              <a:t> </a:t>
+            </a:r>
+            <a:r>
+              <a:rPr dirty="0"/>
+              <a:t>DDPM generates synthetic radio galaxies</a:t>
+            </a:r>
+          </a:p>
+          <a:p>
+            <a:pPr>
+              <a:spcAft>
+                <a:spcPts val="1000"/>
+              </a:spcAft>
+              <a:defRPr sz="2200">
+                <a:solidFill>
+                  <a:srgbClr val="222222"/>
+                </a:solidFill>
+              </a:defRPr>
+            </a:pPr>
+            <a:r>
+              <a:rPr dirty="0"/>
+              <a:t>•  3. Physics-informed constraints — bilateral symmetry + non-negative flux losse</a:t>
+            </a:r>
+            <a:r>
+              <a:rPr lang="en-US" dirty="0"/>
+              <a:t>s</a:t>
+            </a:r>
+          </a:p>
+          <a:p>
+            <a:pPr>
+              <a:spcAft>
+                <a:spcPts val="1000"/>
+              </a:spcAft>
+              <a:defRPr sz="2200">
+                <a:solidFill>
+                  <a:srgbClr val="222222"/>
+                </a:solidFill>
+              </a:defRPr>
+            </a:pPr>
+            <a:r>
+              <a:rPr lang="en-ZA" dirty="0"/>
+              <a:t>•  4. </a:t>
+            </a:r>
+            <a:r>
+              <a:rPr lang="en-US" dirty="0"/>
+              <a:t>Incorporate physical constraints during training, classifier guidance during second stage of diffusion training.</a:t>
+            </a:r>
+          </a:p>
+          <a:p>
+            <a:pPr>
+              <a:spcAft>
+                <a:spcPts val="1000"/>
+              </a:spcAft>
+              <a:defRPr sz="2200">
+                <a:solidFill>
+                  <a:srgbClr val="222222"/>
+                </a:solidFill>
+              </a:defRPr>
+            </a:pPr>
+            <a:br>
+              <a:rPr lang="en-US" dirty="0"/>
+            </a:br>
+            <a:r>
+              <a:rPr dirty="0"/>
+              <a:t>•  Goal: generate physically-plausible, class-faithful synthetic radio galaxies to augment scarce labeled data</a:t>
+            </a:r>
+          </a:p>
+        </p:txBody>
+      </p:sp>
+    </p:spTree>
+  </p:cSld>
+  <p:clrMapOvr>
+    <a:masterClrMapping/>
+  </p:clrMapOvr>
+</p:sld>
+</file>
+
+<file path=ppt/slides/slide7.xml><?xml version="1.0" encoding="utf-8"?>
+<p:sld xmlns:a="http://schemas.openxmlformats.org/drawingml/2006/main" xmlns:r="http://schemas.openxmlformats.org/officeDocument/2006/relationships" xmlns:p="http://schemas.openxmlformats.org/presentationml/2006/main">
+  <p:cSld>
+    <p:spTree>
+      <p:nvGrpSpPr>
+        <p:cNvPr id="1" name=""/>
+        <p:cNvGrpSpPr/>
+        <p:nvPr/>
+      </p:nvGrpSpPr>
+      <p:grpSpPr>
+        <a:xfrm>
+          <a:off x="0" y="0"/>
+          <a:ext cx="0" cy="0"/>
+          <a:chOff x="0" y="0"/>
+          <a:chExt cx="0" cy="0"/>
+        </a:xfrm>
+      </p:grpSpPr>
+      <p:sp>
+        <p:nvSpPr>
+          <p:cNvPr id="2" name="TextBox 1"/>
+          <p:cNvSpPr txBox="1"/>
+          <p:nvPr/>
+        </p:nvSpPr>
+        <p:spPr>
+          <a:xfrm>
+            <a:off x="548640" y="320040"/>
+            <a:ext cx="11094415" cy="914400"/>
+          </a:xfrm>
+          <a:prstGeom prst="rect">
+            <a:avLst/>
+          </a:prstGeom>
+          <a:noFill/>
+        </p:spPr>
+        <p:txBody>
+          <a:bodyPr wrap="square">
+            <a:spAutoFit/>
+          </a:bodyPr>
+          <a:lstStyle/>
+          <a:p>
+            <a:pPr>
+              <a:defRPr sz="3600" b="1">
+                <a:solidFill>
+                  <a:srgbClr val="1B2A4A"/>
+                </a:solidFill>
+              </a:defRPr>
+            </a:pPr>
+            <a:r>
+              <a:t>Classification Results</a:t>
+            </a:r>
+          </a:p>
+        </p:txBody>
+      </p:sp>
+      <p:sp>
+        <p:nvSpPr>
+          <p:cNvPr id="3" name="Rectangle 2"/>
+          <p:cNvSpPr/>
+          <p:nvPr/>
+        </p:nvSpPr>
+        <p:spPr>
+          <a:xfrm>
+            <a:off x="548640" y="1143000"/>
+            <a:ext cx="2011680" cy="38100"/>
+          </a:xfrm>
+          <a:prstGeom prst="rect">
+            <a:avLst/>
+          </a:prstGeom>
+          <a:solidFill>
+            <a:srgbClr val="2E86C1"/>
+          </a:solidFill>
+          <a:ln>
+            <a:noFill/>
+          </a:ln>
+        </p:spPr>
+        <p:style>
+          <a:lnRef idx="1">
+            <a:schemeClr val="accent1"/>
+          </a:lnRef>
+          <a:fillRef idx="3">
+            <a:schemeClr val="accent1"/>
+          </a:fillRef>
+          <a:effectRef idx="2">
+            <a:schemeClr val="accent1"/>
+          </a:effectRef>
+          <a:fontRef idx="minor">
+            <a:schemeClr val="lt1"/>
+          </a:fontRef>
+        </p:style>
+        <p:txBody>
+          <a:bodyPr rtlCol="0" anchor="ctr"/>
+          <a:lstStyle/>
+          <a:p>
+            <a:pPr algn="ctr"/>
+            <a:endParaRPr/>
+          </a:p>
+        </p:txBody>
+      </p:sp>
+      <p:sp>
+        <p:nvSpPr>
+          <p:cNvPr id="4" name="TextBox 3"/>
+          <p:cNvSpPr txBox="1"/>
+          <p:nvPr/>
+        </p:nvSpPr>
+        <p:spPr>
+          <a:xfrm>
+            <a:off x="548640" y="1417320"/>
+            <a:ext cx="5120640" cy="2743200"/>
+          </a:xfrm>
+          <a:prstGeom prst="rect">
+            <a:avLst/>
+          </a:prstGeom>
+          <a:noFill/>
+        </p:spPr>
+        <p:txBody>
+          <a:bodyPr wrap="square">
+            <a:spAutoFit/>
+          </a:bodyPr>
+          <a:lstStyle/>
+          <a:p>
+            <a:pPr>
+              <a:spcAft>
+                <a:spcPts val="1000"/>
+              </a:spcAft>
+              <a:defRPr sz="2000">
+                <a:solidFill>
+                  <a:srgbClr val="222222"/>
+                </a:solidFill>
+              </a:defRPr>
+            </a:pPr>
+            <a:r>
+              <a:rPr dirty="0"/>
+              <a:t>•  </a:t>
+            </a:r>
+            <a:r>
+              <a:rPr dirty="0" err="1"/>
+              <a:t>MiraBest</a:t>
+            </a:r>
+            <a:r>
+              <a:rPr dirty="0"/>
+              <a:t>: ~90% test accuracy, consistent across multiple runs (88–94%)</a:t>
+            </a:r>
+          </a:p>
+          <a:p>
+            <a:pPr>
+              <a:spcAft>
+                <a:spcPts val="1000"/>
+              </a:spcAft>
+              <a:defRPr sz="2000">
+                <a:solidFill>
+                  <a:srgbClr val="222222"/>
+                </a:solidFill>
+              </a:defRPr>
+            </a:pPr>
+            <a:r>
+              <a:rPr dirty="0"/>
+              <a:t>•  Independently verified: a random-sample check of the saved model got 90/100 correct</a:t>
             </a:r>
           </a:p>
         </p:txBody>
       </p:sp>
       <p:pic>
         <p:nvPicPr>
-          <p:cNvPr id="5" name="Picture 4" descr="comparison_epoch_285.png"/>
+          <p:cNvPr id="5" name="Picture 4" descr="confusion_matrix.png"/>
           <p:cNvPicPr>
             <a:picLocks noChangeAspect="1"/>
           </p:cNvPicPr>
@@ -5664,8 +5966,8 @@
         </p:blipFill>
         <p:spPr>
           <a:xfrm>
-            <a:off x="2880360" y="3200400"/>
-            <a:ext cx="6400800" cy="3200400"/>
+            <a:off x="6035040" y="1748790"/>
+            <a:ext cx="5577840" cy="4183380"/>
           </a:xfrm>
           <a:prstGeom prst="rect">
             <a:avLst/>
@@ -5680,8 +5982,8 @@
         </p:nvSpPr>
         <p:spPr>
           <a:xfrm>
-            <a:off x="2286000" y="6446520"/>
-            <a:ext cx="7589520" cy="365760"/>
+            <a:off x="6035040" y="6172200"/>
+            <a:ext cx="5577840" cy="365760"/>
           </a:xfrm>
           <a:prstGeom prst="rect">
             <a:avLst/>
@@ -5702,7 +6004,441 @@
               </a:defRPr>
             </a:pPr>
             <a:r>
-              <a:t>PID-generated samples, epoch 285 — FR-I vs FR-II</a:t>
+              <a:t>MiraBest confusion matrix — 90.9% accuracy</a:t>
+            </a:r>
+          </a:p>
+        </p:txBody>
+      </p:sp>
+    </p:spTree>
+  </p:cSld>
+  <p:clrMapOvr>
+    <a:masterClrMapping/>
+  </p:clrMapOvr>
+</p:sld>
+</file>
+
+<file path=ppt/slides/slide8.xml><?xml version="1.0" encoding="utf-8"?>
+<p:sld xmlns:a="http://schemas.openxmlformats.org/drawingml/2006/main" xmlns:r="http://schemas.openxmlformats.org/officeDocument/2006/relationships" xmlns:p="http://schemas.openxmlformats.org/presentationml/2006/main" show="0">
+  <p:cSld>
+    <p:spTree>
+      <p:nvGrpSpPr>
+        <p:cNvPr id="1" name=""/>
+        <p:cNvGrpSpPr/>
+        <p:nvPr/>
+      </p:nvGrpSpPr>
+      <p:grpSpPr>
+        <a:xfrm>
+          <a:off x="0" y="0"/>
+          <a:ext cx="0" cy="0"/>
+          <a:chOff x="0" y="0"/>
+          <a:chExt cx="0" cy="0"/>
+        </a:xfrm>
+      </p:grpSpPr>
+      <p:sp>
+        <p:nvSpPr>
+          <p:cNvPr id="2" name="TextBox 1"/>
+          <p:cNvSpPr txBox="1"/>
+          <p:nvPr/>
+        </p:nvSpPr>
+        <p:spPr>
+          <a:xfrm>
+            <a:off x="548640" y="320040"/>
+            <a:ext cx="11094415" cy="914400"/>
+          </a:xfrm>
+          <a:prstGeom prst="rect">
+            <a:avLst/>
+          </a:prstGeom>
+          <a:noFill/>
+        </p:spPr>
+        <p:txBody>
+          <a:bodyPr wrap="square">
+            <a:spAutoFit/>
+          </a:bodyPr>
+          <a:lstStyle/>
+          <a:p>
+            <a:pPr>
+              <a:defRPr sz="3600" b="1">
+                <a:solidFill>
+                  <a:srgbClr val="1B2A4A"/>
+                </a:solidFill>
+              </a:defRPr>
+            </a:pPr>
+            <a:r>
+              <a:t>ResNet18: What We're Fine-Tuning</a:t>
+            </a:r>
+          </a:p>
+        </p:txBody>
+      </p:sp>
+      <p:sp>
+        <p:nvSpPr>
+          <p:cNvPr id="3" name="Rectangle 2"/>
+          <p:cNvSpPr/>
+          <p:nvPr/>
+        </p:nvSpPr>
+        <p:spPr>
+          <a:xfrm>
+            <a:off x="548640" y="1143000"/>
+            <a:ext cx="2011680" cy="38100"/>
+          </a:xfrm>
+          <a:prstGeom prst="rect">
+            <a:avLst/>
+          </a:prstGeom>
+          <a:solidFill>
+            <a:srgbClr val="2E86C1"/>
+          </a:solidFill>
+          <a:ln>
+            <a:noFill/>
+          </a:ln>
+        </p:spPr>
+        <p:style>
+          <a:lnRef idx="1">
+            <a:schemeClr val="accent1"/>
+          </a:lnRef>
+          <a:fillRef idx="3">
+            <a:schemeClr val="accent1"/>
+          </a:fillRef>
+          <a:effectRef idx="2">
+            <a:schemeClr val="accent1"/>
+          </a:effectRef>
+          <a:fontRef idx="minor">
+            <a:schemeClr val="lt1"/>
+          </a:fontRef>
+        </p:style>
+        <p:txBody>
+          <a:bodyPr rtlCol="0" anchor="ctr"/>
+          <a:lstStyle/>
+          <a:p>
+            <a:pPr algn="ctr"/>
+            <a:endParaRPr/>
+          </a:p>
+        </p:txBody>
+      </p:sp>
+      <p:sp>
+        <p:nvSpPr>
+          <p:cNvPr id="4" name="TextBox 3"/>
+          <p:cNvSpPr txBox="1"/>
+          <p:nvPr/>
+        </p:nvSpPr>
+        <p:spPr>
+          <a:xfrm>
+            <a:off x="548640" y="1417320"/>
+            <a:ext cx="10972800" cy="2377440"/>
+          </a:xfrm>
+          <a:prstGeom prst="rect">
+            <a:avLst/>
+          </a:prstGeom>
+          <a:noFill/>
+        </p:spPr>
+        <p:txBody>
+          <a:bodyPr wrap="square">
+            <a:spAutoFit/>
+          </a:bodyPr>
+          <a:lstStyle/>
+          <a:p>
+            <a:pPr>
+              <a:spcAft>
+                <a:spcPts val="1000"/>
+              </a:spcAft>
+              <a:defRPr sz="1800">
+                <a:solidFill>
+                  <a:srgbClr val="222222"/>
+                </a:solidFill>
+              </a:defRPr>
+            </a:pPr>
+            <a:r>
+              <a:rPr dirty="0"/>
+              <a:t>•  ResNet18 has ~11.2 million parameters, arranged in a stem + 4 residual "layer" blocks + a final classification head</a:t>
+            </a:r>
+          </a:p>
+          <a:p>
+            <a:pPr>
+              <a:spcAft>
+                <a:spcPts val="1000"/>
+              </a:spcAft>
+              <a:defRPr sz="1800">
+                <a:solidFill>
+                  <a:srgbClr val="222222"/>
+                </a:solidFill>
+              </a:defRPr>
+            </a:pPr>
+            <a:r>
+              <a:rPr dirty="0"/>
+              <a:t>•  Pretrained on ImageNet (natural photos) — the early layers learn general shape/edge features that transfer reasonably well</a:t>
+            </a:r>
+          </a:p>
+          <a:p>
+            <a:pPr>
+              <a:spcAft>
+                <a:spcPts val="1000"/>
+              </a:spcAft>
+              <a:defRPr sz="1800">
+                <a:solidFill>
+                  <a:srgbClr val="222222"/>
+                </a:solidFill>
+              </a:defRPr>
+            </a:pPr>
+            <a:r>
+              <a:rPr dirty="0"/>
+              <a:t>•  We freeze layer1–layer3 (the early/mid layers) and only fine-tune layer4 + the head on our radio galaxy images</a:t>
+            </a:r>
+          </a:p>
+          <a:p>
+            <a:pPr>
+              <a:spcAft>
+                <a:spcPts val="1000"/>
+              </a:spcAft>
+              <a:defRPr sz="1800">
+                <a:solidFill>
+                  <a:srgbClr val="222222"/>
+                </a:solidFill>
+              </a:defRPr>
+            </a:pPr>
+            <a:r>
+              <a:rPr dirty="0"/>
+              <a:t>•  layer4 still holds ~75% of all parameters — so "only fine-tuning one block" is not as small a change as it sounds</a:t>
+            </a:r>
+          </a:p>
+        </p:txBody>
+      </p:sp>
+      <p:pic>
+        <p:nvPicPr>
+          <p:cNvPr id="5" name="Picture 4" descr="resnet18_finetune_diagram.png"/>
+          <p:cNvPicPr>
+            <a:picLocks noChangeAspect="1"/>
+          </p:cNvPicPr>
+          <p:nvPr/>
+        </p:nvPicPr>
+        <p:blipFill>
+          <a:blip r:embed="rId2"/>
+          <a:stretch>
+            <a:fillRect/>
+          </a:stretch>
+        </p:blipFill>
+        <p:spPr>
+          <a:xfrm>
+            <a:off x="1999567" y="3931920"/>
+            <a:ext cx="8162385" cy="2651760"/>
+          </a:xfrm>
+          <a:prstGeom prst="rect">
+            <a:avLst/>
+          </a:prstGeom>
+        </p:spPr>
+      </p:pic>
+    </p:spTree>
+  </p:cSld>
+  <p:clrMapOvr>
+    <a:masterClrMapping/>
+  </p:clrMapOvr>
+</p:sld>
+</file>
+
+<file path=ppt/slides/slide9.xml><?xml version="1.0" encoding="utf-8"?>
+<p:sld xmlns:a="http://schemas.openxmlformats.org/drawingml/2006/main" xmlns:r="http://schemas.openxmlformats.org/officeDocument/2006/relationships" xmlns:p="http://schemas.openxmlformats.org/presentationml/2006/main">
+  <p:cSld>
+    <p:spTree>
+      <p:nvGrpSpPr>
+        <p:cNvPr id="1" name=""/>
+        <p:cNvGrpSpPr/>
+        <p:nvPr/>
+      </p:nvGrpSpPr>
+      <p:grpSpPr>
+        <a:xfrm>
+          <a:off x="0" y="0"/>
+          <a:ext cx="0" cy="0"/>
+          <a:chOff x="0" y="0"/>
+          <a:chExt cx="0" cy="0"/>
+        </a:xfrm>
+      </p:grpSpPr>
+      <p:sp>
+        <p:nvSpPr>
+          <p:cNvPr id="2" name="TextBox 1"/>
+          <p:cNvSpPr txBox="1"/>
+          <p:nvPr/>
+        </p:nvSpPr>
+        <p:spPr>
+          <a:xfrm>
+            <a:off x="548640" y="320040"/>
+            <a:ext cx="11094415" cy="914400"/>
+          </a:xfrm>
+          <a:prstGeom prst="rect">
+            <a:avLst/>
+          </a:prstGeom>
+          <a:noFill/>
+        </p:spPr>
+        <p:txBody>
+          <a:bodyPr wrap="square">
+            <a:spAutoFit/>
+          </a:bodyPr>
+          <a:lstStyle/>
+          <a:p>
+            <a:pPr>
+              <a:defRPr sz="3600" b="1">
+                <a:solidFill>
+                  <a:srgbClr val="1B2A4A"/>
+                </a:solidFill>
+              </a:defRPr>
+            </a:pPr>
+            <a:r>
+              <a:t>Class-Conditional Diffusion Generation</a:t>
+            </a:r>
+          </a:p>
+        </p:txBody>
+      </p:sp>
+      <p:sp>
+        <p:nvSpPr>
+          <p:cNvPr id="3" name="Rectangle 2"/>
+          <p:cNvSpPr/>
+          <p:nvPr/>
+        </p:nvSpPr>
+        <p:spPr>
+          <a:xfrm>
+            <a:off x="548640" y="1143000"/>
+            <a:ext cx="2011680" cy="38100"/>
+          </a:xfrm>
+          <a:prstGeom prst="rect">
+            <a:avLst/>
+          </a:prstGeom>
+          <a:solidFill>
+            <a:srgbClr val="2E86C1"/>
+          </a:solidFill>
+          <a:ln>
+            <a:noFill/>
+          </a:ln>
+        </p:spPr>
+        <p:style>
+          <a:lnRef idx="1">
+            <a:schemeClr val="accent1"/>
+          </a:lnRef>
+          <a:fillRef idx="3">
+            <a:schemeClr val="accent1"/>
+          </a:fillRef>
+          <a:effectRef idx="2">
+            <a:schemeClr val="accent1"/>
+          </a:effectRef>
+          <a:fontRef idx="minor">
+            <a:schemeClr val="lt1"/>
+          </a:fontRef>
+        </p:style>
+        <p:txBody>
+          <a:bodyPr rtlCol="0" anchor="ctr"/>
+          <a:lstStyle/>
+          <a:p>
+            <a:pPr algn="ctr"/>
+            <a:endParaRPr/>
+          </a:p>
+        </p:txBody>
+      </p:sp>
+      <p:sp>
+        <p:nvSpPr>
+          <p:cNvPr id="4" name="TextBox 3"/>
+          <p:cNvSpPr txBox="1"/>
+          <p:nvPr/>
+        </p:nvSpPr>
+        <p:spPr>
+          <a:xfrm>
+            <a:off x="548640" y="1417320"/>
+            <a:ext cx="10972800" cy="836126"/>
+          </a:xfrm>
+          <a:prstGeom prst="rect">
+            <a:avLst/>
+          </a:prstGeom>
+          <a:noFill/>
+        </p:spPr>
+        <p:txBody>
+          <a:bodyPr wrap="square">
+            <a:spAutoFit/>
+          </a:bodyPr>
+          <a:lstStyle/>
+          <a:p>
+            <a:pPr>
+              <a:spcAft>
+                <a:spcPts val="1000"/>
+              </a:spcAft>
+              <a:defRPr sz="2000">
+                <a:solidFill>
+                  <a:srgbClr val="222222"/>
+                </a:solidFill>
+              </a:defRPr>
+            </a:pPr>
+            <a:r>
+              <a:rPr lang="en-ZA" dirty="0"/>
+              <a:t>• Diffusion model</a:t>
+            </a:r>
+            <a:endParaRPr dirty="0"/>
+          </a:p>
+          <a:p>
+            <a:pPr>
+              <a:spcAft>
+                <a:spcPts val="1000"/>
+              </a:spcAft>
+              <a:defRPr sz="2000">
+                <a:solidFill>
+                  <a:srgbClr val="222222"/>
+                </a:solidFill>
+              </a:defRPr>
+            </a:pPr>
+            <a:r>
+              <a:rPr dirty="0"/>
+              <a:t>• Generates distinct FR-I / FR-II morphology after ~250 epochs</a:t>
+            </a:r>
+          </a:p>
+        </p:txBody>
+      </p:sp>
+      <p:pic>
+        <p:nvPicPr>
+          <p:cNvPr id="5" name="Picture 4" descr="comparison_epoch_250.png"/>
+          <p:cNvPicPr>
+            <a:picLocks noChangeAspect="1"/>
+          </p:cNvPicPr>
+          <p:nvPr/>
+        </p:nvPicPr>
+        <p:blipFill>
+          <a:blip r:embed="rId2"/>
+          <a:stretch>
+            <a:fillRect/>
+          </a:stretch>
+        </p:blipFill>
+        <p:spPr>
+          <a:xfrm>
+            <a:off x="2514600" y="2834640"/>
+            <a:ext cx="7132320" cy="3566160"/>
+          </a:xfrm>
+          <a:prstGeom prst="rect">
+            <a:avLst/>
+          </a:prstGeom>
+        </p:spPr>
+      </p:pic>
+      <p:sp>
+        <p:nvSpPr>
+          <p:cNvPr id="6" name="TextBox 5"/>
+          <p:cNvSpPr txBox="1"/>
+          <p:nvPr/>
+        </p:nvSpPr>
+        <p:spPr>
+          <a:xfrm>
+            <a:off x="2286000" y="6400800"/>
+            <a:ext cx="7589520" cy="365760"/>
+          </a:xfrm>
+          <a:prstGeom prst="rect">
+            <a:avLst/>
+          </a:prstGeom>
+          <a:noFill/>
+        </p:spPr>
+        <p:txBody>
+          <a:bodyPr wrap="none">
+            <a:spAutoFit/>
+          </a:bodyPr>
+          <a:lstStyle/>
+          <a:p>
+            <a:pPr algn="ctr">
+              <a:defRPr sz="1300" i="1">
+                <a:solidFill>
+                  <a:srgbClr val="555555"/>
+                </a:solidFill>
+              </a:defRPr>
+            </a:pPr>
+            <a:r>
+              <a:t>Generated samples, epoch 250 — Class 0 (FR-I) vs Class 1 (FR-II)</a:t>
             </a:r>
           </a:p>
         </p:txBody>

</xml_diff>